<commit_message>
final results for first submission
</commit_message>
<xml_diff>
--- a/analysis_data/Results.pptx
+++ b/analysis_data/Results.pptx
@@ -4,14 +4,19 @@
   <p:sldMasterIdLst>
     <p:sldMasterId id="2147483648" r:id="rId1"/>
   </p:sldMasterIdLst>
+  <p:notesMasterIdLst>
+    <p:notesMasterId r:id="rId11"/>
+  </p:notesMasterIdLst>
   <p:sldIdLst>
-    <p:sldId id="259" r:id="rId2"/>
+    <p:sldId id="263" r:id="rId2"/>
     <p:sldId id="262" r:id="rId3"/>
     <p:sldId id="257" r:id="rId4"/>
-    <p:sldId id="256" r:id="rId5"/>
-    <p:sldId id="258" r:id="rId6"/>
-    <p:sldId id="260" r:id="rId7"/>
-    <p:sldId id="263" r:id="rId8"/>
+    <p:sldId id="264" r:id="rId5"/>
+    <p:sldId id="256" r:id="rId6"/>
+    <p:sldId id="258" r:id="rId7"/>
+    <p:sldId id="266" r:id="rId8"/>
+    <p:sldId id="260" r:id="rId9"/>
+    <p:sldId id="265" r:id="rId10"/>
   </p:sldIdLst>
   <p:sldSz cx="12192000" cy="6858000"/>
   <p:notesSz cx="6858000" cy="9144000"/>
@@ -110,7 +115,566 @@
       </a:defRPr>
     </a:lvl9pPr>
   </p:defaultTextStyle>
+  <p:extLst>
+    <p:ext uri="{EFAFB233-063F-42B5-8137-9DF3F51BA10A}">
+      <p15:sldGuideLst xmlns:p15="http://schemas.microsoft.com/office/powerpoint/2012/main"/>
+    </p:ext>
+  </p:extLst>
 </p:presentation>
+</file>
+
+<file path=ppt/notesMasters/notesMaster1.xml><?xml version="1.0" encoding="utf-8"?>
+<p:notesMaster xmlns:a="http://schemas.openxmlformats.org/drawingml/2006/main" xmlns:r="http://schemas.openxmlformats.org/officeDocument/2006/relationships" xmlns:p="http://schemas.openxmlformats.org/presentationml/2006/main">
+  <p:cSld>
+    <p:bg>
+      <p:bgRef idx="1001">
+        <a:schemeClr val="bg1"/>
+      </p:bgRef>
+    </p:bg>
+    <p:spTree>
+      <p:nvGrpSpPr>
+        <p:cNvPr id="1" name=""/>
+        <p:cNvGrpSpPr/>
+        <p:nvPr/>
+      </p:nvGrpSpPr>
+      <p:grpSpPr>
+        <a:xfrm>
+          <a:off x="0" y="0"/>
+          <a:ext cx="0" cy="0"/>
+          <a:chOff x="0" y="0"/>
+          <a:chExt cx="0" cy="0"/>
+        </a:xfrm>
+      </p:grpSpPr>
+      <p:sp>
+        <p:nvSpPr>
+          <p:cNvPr id="2" name="Header Placeholder 1"/>
+          <p:cNvSpPr>
+            <a:spLocks noGrp="1"/>
+          </p:cNvSpPr>
+          <p:nvPr>
+            <p:ph type="hdr" sz="quarter"/>
+          </p:nvPr>
+        </p:nvSpPr>
+        <p:spPr>
+          <a:xfrm>
+            <a:off x="0" y="0"/>
+            <a:ext cx="2971800" cy="458788"/>
+          </a:xfrm>
+          <a:prstGeom prst="rect">
+            <a:avLst/>
+          </a:prstGeom>
+        </p:spPr>
+        <p:txBody>
+          <a:bodyPr vert="horz" lIns="91440" tIns="45720" rIns="91440" bIns="45720" rtlCol="0"/>
+          <a:lstStyle>
+            <a:lvl1pPr algn="l">
+              <a:defRPr sz="1200"/>
+            </a:lvl1pPr>
+          </a:lstStyle>
+          <a:p>
+            <a:endParaRPr lang="nl-NL"/>
+          </a:p>
+        </p:txBody>
+      </p:sp>
+      <p:sp>
+        <p:nvSpPr>
+          <p:cNvPr id="3" name="Date Placeholder 2"/>
+          <p:cNvSpPr>
+            <a:spLocks noGrp="1"/>
+          </p:cNvSpPr>
+          <p:nvPr>
+            <p:ph type="dt" idx="1"/>
+          </p:nvPr>
+        </p:nvSpPr>
+        <p:spPr>
+          <a:xfrm>
+            <a:off x="3884613" y="0"/>
+            <a:ext cx="2971800" cy="458788"/>
+          </a:xfrm>
+          <a:prstGeom prst="rect">
+            <a:avLst/>
+          </a:prstGeom>
+        </p:spPr>
+        <p:txBody>
+          <a:bodyPr vert="horz" lIns="91440" tIns="45720" rIns="91440" bIns="45720" rtlCol="0"/>
+          <a:lstStyle>
+            <a:lvl1pPr algn="r">
+              <a:defRPr sz="1200"/>
+            </a:lvl1pPr>
+          </a:lstStyle>
+          <a:p>
+            <a:fld id="{36322A1A-048E-4317-9FBA-D081DB5FE75A}" type="datetimeFigureOut">
+              <a:rPr lang="nl-NL" smtClean="0"/>
+              <a:t>27-1-2026</a:t>
+            </a:fld>
+            <a:endParaRPr lang="nl-NL"/>
+          </a:p>
+        </p:txBody>
+      </p:sp>
+      <p:sp>
+        <p:nvSpPr>
+          <p:cNvPr id="4" name="Slide Image Placeholder 3"/>
+          <p:cNvSpPr>
+            <a:spLocks noGrp="1" noRot="1" noChangeAspect="1"/>
+          </p:cNvSpPr>
+          <p:nvPr>
+            <p:ph type="sldImg" idx="2"/>
+          </p:nvPr>
+        </p:nvSpPr>
+        <p:spPr>
+          <a:xfrm>
+            <a:off x="685800" y="1143000"/>
+            <a:ext cx="5486400" cy="3086100"/>
+          </a:xfrm>
+          <a:prstGeom prst="rect">
+            <a:avLst/>
+          </a:prstGeom>
+          <a:noFill/>
+          <a:ln w="12700">
+            <a:solidFill>
+              <a:prstClr val="black"/>
+            </a:solidFill>
+          </a:ln>
+        </p:spPr>
+        <p:txBody>
+          <a:bodyPr vert="horz" lIns="91440" tIns="45720" rIns="91440" bIns="45720" rtlCol="0" anchor="ctr"/>
+          <a:lstStyle/>
+          <a:p>
+            <a:endParaRPr lang="nl-NL"/>
+          </a:p>
+        </p:txBody>
+      </p:sp>
+      <p:sp>
+        <p:nvSpPr>
+          <p:cNvPr id="5" name="Notes Placeholder 4"/>
+          <p:cNvSpPr>
+            <a:spLocks noGrp="1"/>
+          </p:cNvSpPr>
+          <p:nvPr>
+            <p:ph type="body" sz="quarter" idx="3"/>
+          </p:nvPr>
+        </p:nvSpPr>
+        <p:spPr>
+          <a:xfrm>
+            <a:off x="685800" y="4400550"/>
+            <a:ext cx="5486400" cy="3600450"/>
+          </a:xfrm>
+          <a:prstGeom prst="rect">
+            <a:avLst/>
+          </a:prstGeom>
+        </p:spPr>
+        <p:txBody>
+          <a:bodyPr vert="horz" lIns="91440" tIns="45720" rIns="91440" bIns="45720" rtlCol="0"/>
+          <a:lstStyle/>
+          <a:p>
+            <a:pPr lvl="0"/>
+            <a:r>
+              <a:rPr lang="en-US"/>
+              <a:t>Click to edit Master text styles</a:t>
+            </a:r>
+          </a:p>
+          <a:p>
+            <a:pPr lvl="1"/>
+            <a:r>
+              <a:rPr lang="en-US"/>
+              <a:t>Second level</a:t>
+            </a:r>
+          </a:p>
+          <a:p>
+            <a:pPr lvl="2"/>
+            <a:r>
+              <a:rPr lang="en-US"/>
+              <a:t>Third level</a:t>
+            </a:r>
+          </a:p>
+          <a:p>
+            <a:pPr lvl="3"/>
+            <a:r>
+              <a:rPr lang="en-US"/>
+              <a:t>Fourth level</a:t>
+            </a:r>
+          </a:p>
+          <a:p>
+            <a:pPr lvl="4"/>
+            <a:r>
+              <a:rPr lang="en-US"/>
+              <a:t>Fifth level</a:t>
+            </a:r>
+            <a:endParaRPr lang="nl-NL"/>
+          </a:p>
+        </p:txBody>
+      </p:sp>
+      <p:sp>
+        <p:nvSpPr>
+          <p:cNvPr id="6" name="Footer Placeholder 5"/>
+          <p:cNvSpPr>
+            <a:spLocks noGrp="1"/>
+          </p:cNvSpPr>
+          <p:nvPr>
+            <p:ph type="ftr" sz="quarter" idx="4"/>
+          </p:nvPr>
+        </p:nvSpPr>
+        <p:spPr>
+          <a:xfrm>
+            <a:off x="0" y="8685213"/>
+            <a:ext cx="2971800" cy="458787"/>
+          </a:xfrm>
+          <a:prstGeom prst="rect">
+            <a:avLst/>
+          </a:prstGeom>
+        </p:spPr>
+        <p:txBody>
+          <a:bodyPr vert="horz" lIns="91440" tIns="45720" rIns="91440" bIns="45720" rtlCol="0" anchor="b"/>
+          <a:lstStyle>
+            <a:lvl1pPr algn="l">
+              <a:defRPr sz="1200"/>
+            </a:lvl1pPr>
+          </a:lstStyle>
+          <a:p>
+            <a:endParaRPr lang="nl-NL"/>
+          </a:p>
+        </p:txBody>
+      </p:sp>
+      <p:sp>
+        <p:nvSpPr>
+          <p:cNvPr id="7" name="Slide Number Placeholder 6"/>
+          <p:cNvSpPr>
+            <a:spLocks noGrp="1"/>
+          </p:cNvSpPr>
+          <p:nvPr>
+            <p:ph type="sldNum" sz="quarter" idx="5"/>
+          </p:nvPr>
+        </p:nvSpPr>
+        <p:spPr>
+          <a:xfrm>
+            <a:off x="3884613" y="8685213"/>
+            <a:ext cx="2971800" cy="458787"/>
+          </a:xfrm>
+          <a:prstGeom prst="rect">
+            <a:avLst/>
+          </a:prstGeom>
+        </p:spPr>
+        <p:txBody>
+          <a:bodyPr vert="horz" lIns="91440" tIns="45720" rIns="91440" bIns="45720" rtlCol="0" anchor="b"/>
+          <a:lstStyle>
+            <a:lvl1pPr algn="r">
+              <a:defRPr sz="1200"/>
+            </a:lvl1pPr>
+          </a:lstStyle>
+          <a:p>
+            <a:fld id="{C1455716-F041-4BE2-A87B-FB5C9851D850}" type="slidenum">
+              <a:rPr lang="nl-NL" smtClean="0"/>
+              <a:t>‹#›</a:t>
+            </a:fld>
+            <a:endParaRPr lang="nl-NL"/>
+          </a:p>
+        </p:txBody>
+      </p:sp>
+    </p:spTree>
+    <p:extLst>
+      <p:ext uri="{BB962C8B-B14F-4D97-AF65-F5344CB8AC3E}">
+        <p14:creationId xmlns:p14="http://schemas.microsoft.com/office/powerpoint/2010/main" val="3179503752"/>
+      </p:ext>
+    </p:extLst>
+  </p:cSld>
+  <p:clrMap bg1="lt1" tx1="dk1" bg2="lt2" tx2="dk2" accent1="accent1" accent2="accent2" accent3="accent3" accent4="accent4" accent5="accent5" accent6="accent6" hlink="hlink" folHlink="folHlink"/>
+  <p:notesStyle>
+    <a:lvl1pPr marL="0" algn="l" defTabSz="914400" rtl="0" eaLnBrk="1" latinLnBrk="0" hangingPunct="1">
+      <a:defRPr sz="1200" kern="1200">
+        <a:solidFill>
+          <a:schemeClr val="tx1"/>
+        </a:solidFill>
+        <a:latin typeface="+mn-lt"/>
+        <a:ea typeface="+mn-ea"/>
+        <a:cs typeface="+mn-cs"/>
+      </a:defRPr>
+    </a:lvl1pPr>
+    <a:lvl2pPr marL="457200" algn="l" defTabSz="914400" rtl="0" eaLnBrk="1" latinLnBrk="0" hangingPunct="1">
+      <a:defRPr sz="1200" kern="1200">
+        <a:solidFill>
+          <a:schemeClr val="tx1"/>
+        </a:solidFill>
+        <a:latin typeface="+mn-lt"/>
+        <a:ea typeface="+mn-ea"/>
+        <a:cs typeface="+mn-cs"/>
+      </a:defRPr>
+    </a:lvl2pPr>
+    <a:lvl3pPr marL="914400" algn="l" defTabSz="914400" rtl="0" eaLnBrk="1" latinLnBrk="0" hangingPunct="1">
+      <a:defRPr sz="1200" kern="1200">
+        <a:solidFill>
+          <a:schemeClr val="tx1"/>
+        </a:solidFill>
+        <a:latin typeface="+mn-lt"/>
+        <a:ea typeface="+mn-ea"/>
+        <a:cs typeface="+mn-cs"/>
+      </a:defRPr>
+    </a:lvl3pPr>
+    <a:lvl4pPr marL="1371600" algn="l" defTabSz="914400" rtl="0" eaLnBrk="1" latinLnBrk="0" hangingPunct="1">
+      <a:defRPr sz="1200" kern="1200">
+        <a:solidFill>
+          <a:schemeClr val="tx1"/>
+        </a:solidFill>
+        <a:latin typeface="+mn-lt"/>
+        <a:ea typeface="+mn-ea"/>
+        <a:cs typeface="+mn-cs"/>
+      </a:defRPr>
+    </a:lvl4pPr>
+    <a:lvl5pPr marL="1828800" algn="l" defTabSz="914400" rtl="0" eaLnBrk="1" latinLnBrk="0" hangingPunct="1">
+      <a:defRPr sz="1200" kern="1200">
+        <a:solidFill>
+          <a:schemeClr val="tx1"/>
+        </a:solidFill>
+        <a:latin typeface="+mn-lt"/>
+        <a:ea typeface="+mn-ea"/>
+        <a:cs typeface="+mn-cs"/>
+      </a:defRPr>
+    </a:lvl5pPr>
+    <a:lvl6pPr marL="2286000" algn="l" defTabSz="914400" rtl="0" eaLnBrk="1" latinLnBrk="0" hangingPunct="1">
+      <a:defRPr sz="1200" kern="1200">
+        <a:solidFill>
+          <a:schemeClr val="tx1"/>
+        </a:solidFill>
+        <a:latin typeface="+mn-lt"/>
+        <a:ea typeface="+mn-ea"/>
+        <a:cs typeface="+mn-cs"/>
+      </a:defRPr>
+    </a:lvl6pPr>
+    <a:lvl7pPr marL="2743200" algn="l" defTabSz="914400" rtl="0" eaLnBrk="1" latinLnBrk="0" hangingPunct="1">
+      <a:defRPr sz="1200" kern="1200">
+        <a:solidFill>
+          <a:schemeClr val="tx1"/>
+        </a:solidFill>
+        <a:latin typeface="+mn-lt"/>
+        <a:ea typeface="+mn-ea"/>
+        <a:cs typeface="+mn-cs"/>
+      </a:defRPr>
+    </a:lvl7pPr>
+    <a:lvl8pPr marL="3200400" algn="l" defTabSz="914400" rtl="0" eaLnBrk="1" latinLnBrk="0" hangingPunct="1">
+      <a:defRPr sz="1200" kern="1200">
+        <a:solidFill>
+          <a:schemeClr val="tx1"/>
+        </a:solidFill>
+        <a:latin typeface="+mn-lt"/>
+        <a:ea typeface="+mn-ea"/>
+        <a:cs typeface="+mn-cs"/>
+      </a:defRPr>
+    </a:lvl8pPr>
+    <a:lvl9pPr marL="3657600" algn="l" defTabSz="914400" rtl="0" eaLnBrk="1" latinLnBrk="0" hangingPunct="1">
+      <a:defRPr sz="1200" kern="1200">
+        <a:solidFill>
+          <a:schemeClr val="tx1"/>
+        </a:solidFill>
+        <a:latin typeface="+mn-lt"/>
+        <a:ea typeface="+mn-ea"/>
+        <a:cs typeface="+mn-cs"/>
+      </a:defRPr>
+    </a:lvl9pPr>
+  </p:notesStyle>
+</p:notesMaster>
+</file>
+
+<file path=ppt/notesSlides/notesSlide1.xml><?xml version="1.0" encoding="utf-8"?>
+<p:notes xmlns:a="http://schemas.openxmlformats.org/drawingml/2006/main" xmlns:r="http://schemas.openxmlformats.org/officeDocument/2006/relationships" xmlns:p="http://schemas.openxmlformats.org/presentationml/2006/main">
+  <p:cSld>
+    <p:spTree>
+      <p:nvGrpSpPr>
+        <p:cNvPr id="1" name=""/>
+        <p:cNvGrpSpPr/>
+        <p:nvPr/>
+      </p:nvGrpSpPr>
+      <p:grpSpPr>
+        <a:xfrm>
+          <a:off x="0" y="0"/>
+          <a:ext cx="0" cy="0"/>
+          <a:chOff x="0" y="0"/>
+          <a:chExt cx="0" cy="0"/>
+        </a:xfrm>
+      </p:grpSpPr>
+      <p:sp>
+        <p:nvSpPr>
+          <p:cNvPr id="2" name="Slide Image Placeholder 1"/>
+          <p:cNvSpPr>
+            <a:spLocks noGrp="1" noRot="1" noChangeAspect="1"/>
+          </p:cNvSpPr>
+          <p:nvPr>
+            <p:ph type="sldImg"/>
+          </p:nvPr>
+        </p:nvSpPr>
+        <p:spPr/>
+      </p:sp>
+      <p:sp>
+        <p:nvSpPr>
+          <p:cNvPr id="3" name="Notes Placeholder 2"/>
+          <p:cNvSpPr>
+            <a:spLocks noGrp="1"/>
+          </p:cNvSpPr>
+          <p:nvPr>
+            <p:ph type="body" idx="1"/>
+          </p:nvPr>
+        </p:nvSpPr>
+        <p:spPr/>
+        <p:txBody>
+          <a:bodyPr/>
+          <a:lstStyle/>
+          <a:p>
+            <a:r>
+              <a:rPr lang="en-US" dirty="0"/>
+              <a:t>Assess peak demand served</a:t>
+            </a:r>
+          </a:p>
+          <a:p>
+            <a:r>
+              <a:rPr lang="en-US" dirty="0"/>
+              <a:t>Does the locational difference in investment impact the demand served?</a:t>
+            </a:r>
+            <a:endParaRPr lang="nl-NL" dirty="0"/>
+          </a:p>
+        </p:txBody>
+      </p:sp>
+      <p:sp>
+        <p:nvSpPr>
+          <p:cNvPr id="4" name="Slide Number Placeholder 3"/>
+          <p:cNvSpPr>
+            <a:spLocks noGrp="1"/>
+          </p:cNvSpPr>
+          <p:nvPr>
+            <p:ph type="sldNum" sz="quarter" idx="5"/>
+          </p:nvPr>
+        </p:nvSpPr>
+        <p:spPr/>
+        <p:txBody>
+          <a:bodyPr/>
+          <a:lstStyle/>
+          <a:p>
+            <a:fld id="{C1455716-F041-4BE2-A87B-FB5C9851D850}" type="slidenum">
+              <a:rPr lang="nl-NL" smtClean="0"/>
+              <a:t>2</a:t>
+            </a:fld>
+            <a:endParaRPr lang="nl-NL"/>
+          </a:p>
+        </p:txBody>
+      </p:sp>
+    </p:spTree>
+    <p:extLst>
+      <p:ext uri="{BB962C8B-B14F-4D97-AF65-F5344CB8AC3E}">
+        <p14:creationId xmlns:p14="http://schemas.microsoft.com/office/powerpoint/2010/main" val="503954032"/>
+      </p:ext>
+    </p:extLst>
+  </p:cSld>
+  <p:clrMapOvr>
+    <a:masterClrMapping/>
+  </p:clrMapOvr>
+</p:notes>
+</file>
+
+<file path=ppt/notesSlides/notesSlide2.xml><?xml version="1.0" encoding="utf-8"?>
+<p:notes xmlns:a="http://schemas.openxmlformats.org/drawingml/2006/main" xmlns:r="http://schemas.openxmlformats.org/officeDocument/2006/relationships" xmlns:p="http://schemas.openxmlformats.org/presentationml/2006/main">
+  <p:cSld>
+    <p:spTree>
+      <p:nvGrpSpPr>
+        <p:cNvPr id="1" name=""/>
+        <p:cNvGrpSpPr/>
+        <p:nvPr/>
+      </p:nvGrpSpPr>
+      <p:grpSpPr>
+        <a:xfrm>
+          <a:off x="0" y="0"/>
+          <a:ext cx="0" cy="0"/>
+          <a:chOff x="0" y="0"/>
+          <a:chExt cx="0" cy="0"/>
+        </a:xfrm>
+      </p:grpSpPr>
+      <p:sp>
+        <p:nvSpPr>
+          <p:cNvPr id="2" name="Slide Image Placeholder 1"/>
+          <p:cNvSpPr>
+            <a:spLocks noGrp="1" noRot="1" noChangeAspect="1"/>
+          </p:cNvSpPr>
+          <p:nvPr>
+            <p:ph type="sldImg"/>
+          </p:nvPr>
+        </p:nvSpPr>
+        <p:spPr/>
+      </p:sp>
+      <p:sp>
+        <p:nvSpPr>
+          <p:cNvPr id="3" name="Notes Placeholder 2"/>
+          <p:cNvSpPr>
+            <a:spLocks noGrp="1"/>
+          </p:cNvSpPr>
+          <p:nvPr>
+            <p:ph type="body" idx="1"/>
+          </p:nvPr>
+        </p:nvSpPr>
+        <p:spPr/>
+        <p:txBody>
+          <a:bodyPr/>
+          <a:lstStyle/>
+          <a:p>
+            <a:r>
+              <a:rPr lang="en-US" dirty="0"/>
+              <a:t>Convert to euros/MWh</a:t>
+            </a:r>
+          </a:p>
+          <a:p>
+            <a:pPr marL="171450" indent="-171450">
+              <a:buFontTx/>
+              <a:buChar char="-"/>
+            </a:pPr>
+            <a:r>
+              <a:rPr lang="en-US" dirty="0"/>
+              <a:t>Price differentials</a:t>
+            </a:r>
+            <a:r>
+              <a:rPr lang="nl-NL" dirty="0"/>
+              <a:t> </a:t>
+            </a:r>
+            <a:r>
+              <a:rPr lang="nl-NL" dirty="0" err="1"/>
+              <a:t>and</a:t>
+            </a:r>
+            <a:r>
+              <a:rPr lang="nl-NL" dirty="0"/>
+              <a:t> flow component</a:t>
+            </a:r>
+            <a:endParaRPr lang="en-US" dirty="0"/>
+          </a:p>
+        </p:txBody>
+      </p:sp>
+      <p:sp>
+        <p:nvSpPr>
+          <p:cNvPr id="4" name="Slide Number Placeholder 3"/>
+          <p:cNvSpPr>
+            <a:spLocks noGrp="1"/>
+          </p:cNvSpPr>
+          <p:nvPr>
+            <p:ph type="sldNum" sz="quarter" idx="5"/>
+          </p:nvPr>
+        </p:nvSpPr>
+        <p:spPr/>
+        <p:txBody>
+          <a:bodyPr/>
+          <a:lstStyle/>
+          <a:p>
+            <a:fld id="{C1455716-F041-4BE2-A87B-FB5C9851D850}" type="slidenum">
+              <a:rPr lang="nl-NL" smtClean="0"/>
+              <a:t>7</a:t>
+            </a:fld>
+            <a:endParaRPr lang="nl-NL"/>
+          </a:p>
+        </p:txBody>
+      </p:sp>
+    </p:spTree>
+    <p:extLst>
+      <p:ext uri="{BB962C8B-B14F-4D97-AF65-F5344CB8AC3E}">
+        <p14:creationId xmlns:p14="http://schemas.microsoft.com/office/powerpoint/2010/main" val="2163428333"/>
+      </p:ext>
+    </p:extLst>
+  </p:cSld>
+  <p:clrMapOvr>
+    <a:masterClrMapping/>
+  </p:clrMapOvr>
+</p:notes>
 </file>
 
 <file path=ppt/slideLayouts/slideLayout1.xml><?xml version="1.0" encoding="utf-8"?>
@@ -262,7 +826,7 @@
           <a:p>
             <a:fld id="{5DA8A44B-ED98-4C4F-858A-0C7247F5ECCE}" type="datetimeFigureOut">
               <a:rPr lang="nl-NL" smtClean="0"/>
-              <a:t>18-1-2026</a:t>
+              <a:t>27-1-2026</a:t>
             </a:fld>
             <a:endParaRPr lang="nl-NL"/>
           </a:p>
@@ -462,7 +1026,7 @@
           <a:p>
             <a:fld id="{5DA8A44B-ED98-4C4F-858A-0C7247F5ECCE}" type="datetimeFigureOut">
               <a:rPr lang="nl-NL" smtClean="0"/>
-              <a:t>18-1-2026</a:t>
+              <a:t>27-1-2026</a:t>
             </a:fld>
             <a:endParaRPr lang="nl-NL"/>
           </a:p>
@@ -672,7 +1236,7 @@
           <a:p>
             <a:fld id="{5DA8A44B-ED98-4C4F-858A-0C7247F5ECCE}" type="datetimeFigureOut">
               <a:rPr lang="nl-NL" smtClean="0"/>
-              <a:t>18-1-2026</a:t>
+              <a:t>27-1-2026</a:t>
             </a:fld>
             <a:endParaRPr lang="nl-NL"/>
           </a:p>
@@ -872,7 +1436,7 @@
           <a:p>
             <a:fld id="{5DA8A44B-ED98-4C4F-858A-0C7247F5ECCE}" type="datetimeFigureOut">
               <a:rPr lang="nl-NL" smtClean="0"/>
-              <a:t>18-1-2026</a:t>
+              <a:t>27-1-2026</a:t>
             </a:fld>
             <a:endParaRPr lang="nl-NL"/>
           </a:p>
@@ -1148,7 +1712,7 @@
           <a:p>
             <a:fld id="{5DA8A44B-ED98-4C4F-858A-0C7247F5ECCE}" type="datetimeFigureOut">
               <a:rPr lang="nl-NL" smtClean="0"/>
-              <a:t>18-1-2026</a:t>
+              <a:t>27-1-2026</a:t>
             </a:fld>
             <a:endParaRPr lang="nl-NL"/>
           </a:p>
@@ -1416,7 +1980,7 @@
           <a:p>
             <a:fld id="{5DA8A44B-ED98-4C4F-858A-0C7247F5ECCE}" type="datetimeFigureOut">
               <a:rPr lang="nl-NL" smtClean="0"/>
-              <a:t>18-1-2026</a:t>
+              <a:t>27-1-2026</a:t>
             </a:fld>
             <a:endParaRPr lang="nl-NL"/>
           </a:p>
@@ -1831,7 +2395,7 @@
           <a:p>
             <a:fld id="{5DA8A44B-ED98-4C4F-858A-0C7247F5ECCE}" type="datetimeFigureOut">
               <a:rPr lang="nl-NL" smtClean="0"/>
-              <a:t>18-1-2026</a:t>
+              <a:t>27-1-2026</a:t>
             </a:fld>
             <a:endParaRPr lang="nl-NL"/>
           </a:p>
@@ -1973,7 +2537,7 @@
           <a:p>
             <a:fld id="{5DA8A44B-ED98-4C4F-858A-0C7247F5ECCE}" type="datetimeFigureOut">
               <a:rPr lang="nl-NL" smtClean="0"/>
-              <a:t>18-1-2026</a:t>
+              <a:t>27-1-2026</a:t>
             </a:fld>
             <a:endParaRPr lang="nl-NL"/>
           </a:p>
@@ -2086,7 +2650,7 @@
           <a:p>
             <a:fld id="{5DA8A44B-ED98-4C4F-858A-0C7247F5ECCE}" type="datetimeFigureOut">
               <a:rPr lang="nl-NL" smtClean="0"/>
-              <a:t>18-1-2026</a:t>
+              <a:t>27-1-2026</a:t>
             </a:fld>
             <a:endParaRPr lang="nl-NL"/>
           </a:p>
@@ -2399,7 +2963,7 @@
           <a:p>
             <a:fld id="{5DA8A44B-ED98-4C4F-858A-0C7247F5ECCE}" type="datetimeFigureOut">
               <a:rPr lang="nl-NL" smtClean="0"/>
-              <a:t>18-1-2026</a:t>
+              <a:t>27-1-2026</a:t>
             </a:fld>
             <a:endParaRPr lang="nl-NL"/>
           </a:p>
@@ -2688,7 +3252,7 @@
           <a:p>
             <a:fld id="{5DA8A44B-ED98-4C4F-858A-0C7247F5ECCE}" type="datetimeFigureOut">
               <a:rPr lang="nl-NL" smtClean="0"/>
-              <a:t>18-1-2026</a:t>
+              <a:t>27-1-2026</a:t>
             </a:fld>
             <a:endParaRPr lang="nl-NL"/>
           </a:p>
@@ -2931,7 +3495,7 @@
           <a:p>
             <a:fld id="{5DA8A44B-ED98-4C4F-858A-0C7247F5ECCE}" type="datetimeFigureOut">
               <a:rPr lang="nl-NL" smtClean="0"/>
-              <a:t>18-1-2026</a:t>
+              <a:t>27-1-2026</a:t>
             </a:fld>
             <a:endParaRPr lang="nl-NL"/>
           </a:p>
@@ -3336,7 +3900,13 @@
   <p:cSld>
     <p:spTree>
       <p:nvGrpSpPr>
-        <p:cNvPr id="1" name=""/>
+        <p:cNvPr id="1" name="">
+          <a:extLst>
+            <a:ext uri="{FF2B5EF4-FFF2-40B4-BE49-F238E27FC236}">
+              <a16:creationId xmlns:a16="http://schemas.microsoft.com/office/drawing/2014/main" id="{59B449D0-6866-447D-8232-865D86112898}"/>
+            </a:ext>
+          </a:extLst>
+        </p:cNvPr>
         <p:cNvGrpSpPr/>
         <p:nvPr/>
       </p:nvGrpSpPr>
@@ -3353,7 +3923,7 @@
           <p:cNvPr id="2" name="Title 1">
             <a:extLst>
               <a:ext uri="{FF2B5EF4-FFF2-40B4-BE49-F238E27FC236}">
-                <a16:creationId xmlns:a16="http://schemas.microsoft.com/office/drawing/2014/main" id="{A8AD849A-3323-5CA4-6C56-B9A636EE0065}"/>
+                <a16:creationId xmlns:a16="http://schemas.microsoft.com/office/drawing/2014/main" id="{7C6DC122-5263-0A87-E6A5-529310AD7C04}"/>
               </a:ext>
             </a:extLst>
           </p:cNvPr>
@@ -3371,13 +3941,817 @@
           </a:xfrm>
         </p:spPr>
         <p:txBody>
-          <a:bodyPr/>
+          <a:bodyPr>
+            <a:normAutofit/>
+          </a:bodyPr>
           <a:lstStyle/>
           <a:p>
             <a:pPr algn="ctr"/>
             <a:r>
               <a:rPr lang="en-US" dirty="0"/>
-              <a:t>When all costs are the same</a:t>
+              <a:t>When investment costs of peak unit differ across zones</a:t>
+            </a:r>
+            <a:endParaRPr lang="nl-NL" dirty="0"/>
+          </a:p>
+        </p:txBody>
+      </p:sp>
+      <p:sp>
+        <p:nvSpPr>
+          <p:cNvPr id="4" name="TextBox 3">
+            <a:extLst>
+              <a:ext uri="{FF2B5EF4-FFF2-40B4-BE49-F238E27FC236}">
+                <a16:creationId xmlns:a16="http://schemas.microsoft.com/office/drawing/2014/main" id="{DDF3B06F-262D-1A5F-F4DA-D16A64FC2F0B}"/>
+              </a:ext>
+            </a:extLst>
+          </p:cNvPr>
+          <p:cNvSpPr txBox="1"/>
+          <p:nvPr/>
+        </p:nvSpPr>
+        <p:spPr>
+          <a:xfrm>
+            <a:off x="235218" y="4642120"/>
+            <a:ext cx="2009394" cy="1200329"/>
+          </a:xfrm>
+          <a:prstGeom prst="rect">
+            <a:avLst/>
+          </a:prstGeom>
+          <a:noFill/>
+        </p:spPr>
+        <p:txBody>
+          <a:bodyPr wrap="square">
+            <a:spAutoFit/>
+          </a:bodyPr>
+          <a:lstStyle/>
+          <a:p>
+            <a:r>
+              <a:rPr lang="en-US" dirty="0"/>
+              <a:t>Zone A: 60k€/MW</a:t>
+            </a:r>
+          </a:p>
+          <a:p>
+            <a:r>
+              <a:rPr lang="en-US" dirty="0"/>
+              <a:t>Zone B: 70k€/MW</a:t>
+            </a:r>
+          </a:p>
+          <a:p>
+            <a:r>
+              <a:rPr lang="en-US" dirty="0"/>
+              <a:t>Zone C: 80k€/MW</a:t>
+            </a:r>
+          </a:p>
+          <a:p>
+            <a:endParaRPr lang="nl-NL" dirty="0"/>
+          </a:p>
+        </p:txBody>
+      </p:sp>
+      <p:sp>
+        <p:nvSpPr>
+          <p:cNvPr id="5" name="TextBox 4">
+            <a:extLst>
+              <a:ext uri="{FF2B5EF4-FFF2-40B4-BE49-F238E27FC236}">
+                <a16:creationId xmlns:a16="http://schemas.microsoft.com/office/drawing/2014/main" id="{45773A38-FF4B-6595-9AC4-A645FCAFB365}"/>
+              </a:ext>
+            </a:extLst>
+          </p:cNvPr>
+          <p:cNvSpPr txBox="1"/>
+          <p:nvPr/>
+        </p:nvSpPr>
+        <p:spPr>
+          <a:xfrm>
+            <a:off x="331470" y="4080456"/>
+            <a:ext cx="3291840" cy="646331"/>
+          </a:xfrm>
+          <a:prstGeom prst="rect">
+            <a:avLst/>
+          </a:prstGeom>
+          <a:noFill/>
+        </p:spPr>
+        <p:txBody>
+          <a:bodyPr wrap="square">
+            <a:spAutoFit/>
+          </a:bodyPr>
+          <a:lstStyle/>
+          <a:p>
+            <a:r>
+              <a:rPr lang="en-US" dirty="0"/>
+              <a:t>Previously, All zones had same investment costs</a:t>
+            </a:r>
+            <a:endParaRPr lang="nl-NL" dirty="0"/>
+          </a:p>
+        </p:txBody>
+      </p:sp>
+      <p:sp>
+        <p:nvSpPr>
+          <p:cNvPr id="6" name="TextBox 5">
+            <a:extLst>
+              <a:ext uri="{FF2B5EF4-FFF2-40B4-BE49-F238E27FC236}">
+                <a16:creationId xmlns:a16="http://schemas.microsoft.com/office/drawing/2014/main" id="{FCB39C7F-C1AD-B3E4-7A81-D06C2CDE1801}"/>
+              </a:ext>
+            </a:extLst>
+          </p:cNvPr>
+          <p:cNvSpPr txBox="1"/>
+          <p:nvPr/>
+        </p:nvSpPr>
+        <p:spPr>
+          <a:xfrm>
+            <a:off x="5049774" y="4403622"/>
+            <a:ext cx="5267706" cy="1363578"/>
+          </a:xfrm>
+          <a:prstGeom prst="rect">
+            <a:avLst/>
+          </a:prstGeom>
+          <a:noFill/>
+        </p:spPr>
+        <p:txBody>
+          <a:bodyPr wrap="square">
+            <a:spAutoFit/>
+          </a:bodyPr>
+          <a:lstStyle/>
+          <a:p>
+            <a:pPr>
+              <a:lnSpc>
+                <a:spcPts val="1425"/>
+              </a:lnSpc>
+              <a:buNone/>
+            </a:pPr>
+            <a:r>
+              <a:rPr lang="pt-BR" b="0" i="1" dirty="0">
+                <a:solidFill>
+                  <a:srgbClr val="FF3F4F"/>
+                </a:solidFill>
+                <a:effectLst/>
+                <a:latin typeface="Consolas" panose="020B0609020204030204" pitchFamily="49" charset="0"/>
+              </a:rPr>
+              <a:t>const</a:t>
+            </a:r>
+            <a:r>
+              <a:rPr lang="pt-BR" b="0" dirty="0">
+                <a:solidFill>
+                  <a:srgbClr val="F8F8F0"/>
+                </a:solidFill>
+                <a:effectLst/>
+                <a:latin typeface="Consolas" panose="020B0609020204030204" pitchFamily="49" charset="0"/>
+              </a:rPr>
+              <a:t> </a:t>
+            </a:r>
+            <a:r>
+              <a:rPr lang="pt-BR" b="0" dirty="0">
+                <a:effectLst/>
+                <a:latin typeface="Consolas" panose="020B0609020204030204" pitchFamily="49" charset="0"/>
+              </a:rPr>
+              <a:t>BRANCHES</a:t>
+            </a:r>
+            <a:r>
+              <a:rPr lang="pt-BR" b="0" dirty="0">
+                <a:solidFill>
+                  <a:srgbClr val="F8F8F0"/>
+                </a:solidFill>
+                <a:effectLst/>
+                <a:latin typeface="Consolas" panose="020B0609020204030204" pitchFamily="49" charset="0"/>
+              </a:rPr>
+              <a:t> </a:t>
+            </a:r>
+            <a:r>
+              <a:rPr lang="pt-BR" b="0" dirty="0">
+                <a:solidFill>
+                  <a:srgbClr val="FF3F4F"/>
+                </a:solidFill>
+                <a:effectLst/>
+                <a:latin typeface="Consolas" panose="020B0609020204030204" pitchFamily="49" charset="0"/>
+              </a:rPr>
+              <a:t>=</a:t>
+            </a:r>
+            <a:r>
+              <a:rPr lang="pt-BR" b="0" dirty="0">
+                <a:solidFill>
+                  <a:srgbClr val="F8F8F0"/>
+                </a:solidFill>
+                <a:effectLst/>
+                <a:latin typeface="Consolas" panose="020B0609020204030204" pitchFamily="49" charset="0"/>
+              </a:rPr>
+              <a:t> </a:t>
+            </a:r>
+            <a:r>
+              <a:rPr lang="pt-BR" b="0" dirty="0">
+                <a:solidFill>
+                  <a:srgbClr val="FF8F3F"/>
+                </a:solidFill>
+                <a:effectLst/>
+                <a:latin typeface="Consolas" panose="020B0609020204030204" pitchFamily="49" charset="0"/>
+              </a:rPr>
+              <a:t>[</a:t>
+            </a:r>
+          </a:p>
+          <a:p>
+            <a:pPr>
+              <a:lnSpc>
+                <a:spcPts val="1425"/>
+              </a:lnSpc>
+              <a:buNone/>
+            </a:pPr>
+            <a:endParaRPr lang="pt-BR" b="0" dirty="0">
+              <a:solidFill>
+                <a:srgbClr val="F8F8F0"/>
+              </a:solidFill>
+              <a:effectLst/>
+              <a:latin typeface="Consolas" panose="020B0609020204030204" pitchFamily="49" charset="0"/>
+            </a:endParaRPr>
+          </a:p>
+          <a:p>
+            <a:pPr>
+              <a:lnSpc>
+                <a:spcPts val="1425"/>
+              </a:lnSpc>
+              <a:buNone/>
+            </a:pPr>
+            <a:r>
+              <a:rPr lang="pt-BR" b="0" dirty="0">
+                <a:solidFill>
+                  <a:srgbClr val="F8F8F0"/>
+                </a:solidFill>
+                <a:effectLst/>
+                <a:latin typeface="Consolas" panose="020B0609020204030204" pitchFamily="49" charset="0"/>
+              </a:rPr>
+              <a:t>    </a:t>
+            </a:r>
+            <a:r>
+              <a:rPr lang="pt-BR" b="0" dirty="0">
+                <a:solidFill>
+                  <a:srgbClr val="FF8F3F"/>
+                </a:solidFill>
+                <a:effectLst/>
+                <a:latin typeface="Consolas" panose="020B0609020204030204" pitchFamily="49" charset="0"/>
+              </a:rPr>
+              <a:t>(</a:t>
+            </a:r>
+            <a:r>
+              <a:rPr lang="pt-BR" b="0" dirty="0">
+                <a:solidFill>
+                  <a:srgbClr val="FD5FF0"/>
+                </a:solidFill>
+                <a:effectLst/>
+                <a:latin typeface="Consolas" panose="020B0609020204030204" pitchFamily="49" charset="0"/>
+              </a:rPr>
+              <a:t>:n1</a:t>
+            </a:r>
+            <a:r>
+              <a:rPr lang="pt-BR" b="0" dirty="0">
+                <a:solidFill>
+                  <a:srgbClr val="F8F8F0"/>
+                </a:solidFill>
+                <a:effectLst/>
+                <a:latin typeface="Consolas" panose="020B0609020204030204" pitchFamily="49" charset="0"/>
+              </a:rPr>
+              <a:t>, </a:t>
+            </a:r>
+            <a:r>
+              <a:rPr lang="pt-BR" b="0" dirty="0">
+                <a:solidFill>
+                  <a:srgbClr val="FD5FF0"/>
+                </a:solidFill>
+                <a:effectLst/>
+                <a:latin typeface="Consolas" panose="020B0609020204030204" pitchFamily="49" charset="0"/>
+              </a:rPr>
+              <a:t>:n2</a:t>
+            </a:r>
+            <a:r>
+              <a:rPr lang="pt-BR" b="0" dirty="0">
+                <a:solidFill>
+                  <a:srgbClr val="F8F8F0"/>
+                </a:solidFill>
+                <a:effectLst/>
+                <a:latin typeface="Consolas" panose="020B0609020204030204" pitchFamily="49" charset="0"/>
+              </a:rPr>
+              <a:t>, </a:t>
+            </a:r>
+            <a:r>
+              <a:rPr lang="pt-BR" b="0" dirty="0">
+                <a:solidFill>
+                  <a:srgbClr val="00AAFF"/>
+                </a:solidFill>
+                <a:effectLst/>
+                <a:latin typeface="Consolas" panose="020B0609020204030204" pitchFamily="49" charset="0"/>
+              </a:rPr>
+              <a:t>500.0</a:t>
+            </a:r>
+            <a:r>
+              <a:rPr lang="pt-BR" b="0" dirty="0">
+                <a:solidFill>
+                  <a:srgbClr val="FF8F3F"/>
+                </a:solidFill>
+                <a:effectLst/>
+                <a:latin typeface="Consolas" panose="020B0609020204030204" pitchFamily="49" charset="0"/>
+              </a:rPr>
+              <a:t>)</a:t>
+            </a:r>
+            <a:r>
+              <a:rPr lang="pt-BR" b="0" dirty="0">
+                <a:solidFill>
+                  <a:srgbClr val="F8F8F0"/>
+                </a:solidFill>
+                <a:effectLst/>
+                <a:latin typeface="Consolas" panose="020B0609020204030204" pitchFamily="49" charset="0"/>
+              </a:rPr>
+              <a:t>,   </a:t>
+            </a:r>
+            <a:r>
+              <a:rPr lang="pt-BR" b="0" i="1" dirty="0">
+                <a:solidFill>
+                  <a:srgbClr val="5C6370"/>
+                </a:solidFill>
+                <a:effectLst/>
+                <a:latin typeface="Consolas" panose="020B0609020204030204" pitchFamily="49" charset="0"/>
+              </a:rPr>
+              <a:t># ℓ₁₂   (A–A)</a:t>
+            </a:r>
+            <a:endParaRPr lang="pt-BR" b="0" dirty="0">
+              <a:solidFill>
+                <a:srgbClr val="F8F8F0"/>
+              </a:solidFill>
+              <a:effectLst/>
+              <a:latin typeface="Consolas" panose="020B0609020204030204" pitchFamily="49" charset="0"/>
+            </a:endParaRPr>
+          </a:p>
+          <a:p>
+            <a:pPr>
+              <a:lnSpc>
+                <a:spcPts val="1425"/>
+              </a:lnSpc>
+              <a:buNone/>
+            </a:pPr>
+            <a:r>
+              <a:rPr lang="pt-BR" b="0" dirty="0">
+                <a:solidFill>
+                  <a:srgbClr val="F8F8F0"/>
+                </a:solidFill>
+                <a:effectLst/>
+                <a:latin typeface="Consolas" panose="020B0609020204030204" pitchFamily="49" charset="0"/>
+              </a:rPr>
+              <a:t>    </a:t>
+            </a:r>
+            <a:r>
+              <a:rPr lang="pt-BR" b="0" dirty="0">
+                <a:solidFill>
+                  <a:srgbClr val="FF8F3F"/>
+                </a:solidFill>
+                <a:effectLst/>
+                <a:latin typeface="Consolas" panose="020B0609020204030204" pitchFamily="49" charset="0"/>
+              </a:rPr>
+              <a:t>(</a:t>
+            </a:r>
+            <a:r>
+              <a:rPr lang="pt-BR" b="0" dirty="0">
+                <a:solidFill>
+                  <a:srgbClr val="FD5FF0"/>
+                </a:solidFill>
+                <a:effectLst/>
+                <a:latin typeface="Consolas" panose="020B0609020204030204" pitchFamily="49" charset="0"/>
+              </a:rPr>
+              <a:t>:n2</a:t>
+            </a:r>
+            <a:r>
+              <a:rPr lang="pt-BR" b="0" dirty="0">
+                <a:solidFill>
+                  <a:srgbClr val="F8F8F0"/>
+                </a:solidFill>
+                <a:effectLst/>
+                <a:latin typeface="Consolas" panose="020B0609020204030204" pitchFamily="49" charset="0"/>
+              </a:rPr>
+              <a:t>, </a:t>
+            </a:r>
+            <a:r>
+              <a:rPr lang="pt-BR" b="0" dirty="0">
+                <a:solidFill>
+                  <a:srgbClr val="FD5FF0"/>
+                </a:solidFill>
+                <a:effectLst/>
+                <a:latin typeface="Consolas" panose="020B0609020204030204" pitchFamily="49" charset="0"/>
+              </a:rPr>
+              <a:t>:n4</a:t>
+            </a:r>
+            <a:r>
+              <a:rPr lang="pt-BR" b="0" dirty="0">
+                <a:solidFill>
+                  <a:srgbClr val="F8F8F0"/>
+                </a:solidFill>
+                <a:effectLst/>
+                <a:latin typeface="Consolas" panose="020B0609020204030204" pitchFamily="49" charset="0"/>
+              </a:rPr>
+              <a:t>, </a:t>
+            </a:r>
+            <a:r>
+              <a:rPr lang="pt-BR" b="0" dirty="0">
+                <a:solidFill>
+                  <a:srgbClr val="00AAFF"/>
+                </a:solidFill>
+                <a:effectLst/>
+                <a:latin typeface="Consolas" panose="020B0609020204030204" pitchFamily="49" charset="0"/>
+              </a:rPr>
+              <a:t>3000.0</a:t>
+            </a:r>
+            <a:r>
+              <a:rPr lang="pt-BR" b="0" dirty="0">
+                <a:solidFill>
+                  <a:srgbClr val="FF8F3F"/>
+                </a:solidFill>
+                <a:effectLst/>
+                <a:latin typeface="Consolas" panose="020B0609020204030204" pitchFamily="49" charset="0"/>
+              </a:rPr>
+              <a:t>)</a:t>
+            </a:r>
+            <a:r>
+              <a:rPr lang="pt-BR" b="0" dirty="0">
+                <a:solidFill>
+                  <a:srgbClr val="F8F8F0"/>
+                </a:solidFill>
+                <a:effectLst/>
+                <a:latin typeface="Consolas" panose="020B0609020204030204" pitchFamily="49" charset="0"/>
+              </a:rPr>
+              <a:t>,   </a:t>
+            </a:r>
+            <a:r>
+              <a:rPr lang="pt-BR" b="0" i="1" dirty="0">
+                <a:solidFill>
+                  <a:srgbClr val="5C6370"/>
+                </a:solidFill>
+                <a:effectLst/>
+                <a:latin typeface="Consolas" panose="020B0609020204030204" pitchFamily="49" charset="0"/>
+              </a:rPr>
+              <a:t># ℓ₂₄   (A–C)</a:t>
+            </a:r>
+            <a:endParaRPr lang="pt-BR" b="0" dirty="0">
+              <a:solidFill>
+                <a:srgbClr val="F8F8F0"/>
+              </a:solidFill>
+              <a:effectLst/>
+              <a:latin typeface="Consolas" panose="020B0609020204030204" pitchFamily="49" charset="0"/>
+            </a:endParaRPr>
+          </a:p>
+          <a:p>
+            <a:pPr>
+              <a:lnSpc>
+                <a:spcPts val="1425"/>
+              </a:lnSpc>
+              <a:buNone/>
+            </a:pPr>
+            <a:r>
+              <a:rPr lang="pt-BR" b="0" dirty="0">
+                <a:solidFill>
+                  <a:srgbClr val="F8F8F0"/>
+                </a:solidFill>
+                <a:effectLst/>
+                <a:latin typeface="Consolas" panose="020B0609020204030204" pitchFamily="49" charset="0"/>
+              </a:rPr>
+              <a:t>    </a:t>
+            </a:r>
+            <a:r>
+              <a:rPr lang="pt-BR" b="0" dirty="0">
+                <a:solidFill>
+                  <a:srgbClr val="FF8F3F"/>
+                </a:solidFill>
+                <a:effectLst/>
+                <a:latin typeface="Consolas" panose="020B0609020204030204" pitchFamily="49" charset="0"/>
+              </a:rPr>
+              <a:t>(</a:t>
+            </a:r>
+            <a:r>
+              <a:rPr lang="pt-BR" b="0" dirty="0">
+                <a:solidFill>
+                  <a:srgbClr val="FD5FF0"/>
+                </a:solidFill>
+                <a:effectLst/>
+                <a:latin typeface="Consolas" panose="020B0609020204030204" pitchFamily="49" charset="0"/>
+              </a:rPr>
+              <a:t>:n4</a:t>
+            </a:r>
+            <a:r>
+              <a:rPr lang="pt-BR" b="0" dirty="0">
+                <a:solidFill>
+                  <a:srgbClr val="F8F8F0"/>
+                </a:solidFill>
+                <a:effectLst/>
+                <a:latin typeface="Consolas" panose="020B0609020204030204" pitchFamily="49" charset="0"/>
+              </a:rPr>
+              <a:t>, </a:t>
+            </a:r>
+            <a:r>
+              <a:rPr lang="pt-BR" b="0" dirty="0">
+                <a:solidFill>
+                  <a:srgbClr val="FD5FF0"/>
+                </a:solidFill>
+                <a:effectLst/>
+                <a:latin typeface="Consolas" panose="020B0609020204030204" pitchFamily="49" charset="0"/>
+              </a:rPr>
+              <a:t>:n3</a:t>
+            </a:r>
+            <a:r>
+              <a:rPr lang="pt-BR" b="0" dirty="0">
+                <a:solidFill>
+                  <a:srgbClr val="F8F8F0"/>
+                </a:solidFill>
+                <a:effectLst/>
+                <a:latin typeface="Consolas" panose="020B0609020204030204" pitchFamily="49" charset="0"/>
+              </a:rPr>
+              <a:t>, </a:t>
+            </a:r>
+            <a:r>
+              <a:rPr lang="pt-BR" b="0" dirty="0">
+                <a:solidFill>
+                  <a:srgbClr val="00AAFF"/>
+                </a:solidFill>
+                <a:effectLst/>
+                <a:latin typeface="Consolas" panose="020B0609020204030204" pitchFamily="49" charset="0"/>
+              </a:rPr>
+              <a:t>3000.0</a:t>
+            </a:r>
+            <a:r>
+              <a:rPr lang="pt-BR" b="0" dirty="0">
+                <a:solidFill>
+                  <a:srgbClr val="FF8F3F"/>
+                </a:solidFill>
+                <a:effectLst/>
+                <a:latin typeface="Consolas" panose="020B0609020204030204" pitchFamily="49" charset="0"/>
+              </a:rPr>
+              <a:t>)</a:t>
+            </a:r>
+            <a:r>
+              <a:rPr lang="pt-BR" b="0" dirty="0">
+                <a:solidFill>
+                  <a:srgbClr val="F8F8F0"/>
+                </a:solidFill>
+                <a:effectLst/>
+                <a:latin typeface="Consolas" panose="020B0609020204030204" pitchFamily="49" charset="0"/>
+              </a:rPr>
+              <a:t>,   </a:t>
+            </a:r>
+            <a:r>
+              <a:rPr lang="pt-BR" b="0" i="1" dirty="0">
+                <a:solidFill>
+                  <a:srgbClr val="5C6370"/>
+                </a:solidFill>
+                <a:effectLst/>
+                <a:latin typeface="Consolas" panose="020B0609020204030204" pitchFamily="49" charset="0"/>
+              </a:rPr>
+              <a:t># ℓ₄₃   (C–B)</a:t>
+            </a:r>
+            <a:endParaRPr lang="pt-BR" b="0" dirty="0">
+              <a:solidFill>
+                <a:srgbClr val="F8F8F0"/>
+              </a:solidFill>
+              <a:effectLst/>
+              <a:latin typeface="Consolas" panose="020B0609020204030204" pitchFamily="49" charset="0"/>
+            </a:endParaRPr>
+          </a:p>
+          <a:p>
+            <a:pPr>
+              <a:lnSpc>
+                <a:spcPts val="1425"/>
+              </a:lnSpc>
+              <a:buNone/>
+            </a:pPr>
+            <a:r>
+              <a:rPr lang="pt-BR" b="0" dirty="0">
+                <a:solidFill>
+                  <a:srgbClr val="F8F8F0"/>
+                </a:solidFill>
+                <a:effectLst/>
+                <a:latin typeface="Consolas" panose="020B0609020204030204" pitchFamily="49" charset="0"/>
+              </a:rPr>
+              <a:t>    </a:t>
+            </a:r>
+            <a:r>
+              <a:rPr lang="pt-BR" b="0" dirty="0">
+                <a:solidFill>
+                  <a:srgbClr val="FF8F3F"/>
+                </a:solidFill>
+                <a:effectLst/>
+                <a:latin typeface="Consolas" panose="020B0609020204030204" pitchFamily="49" charset="0"/>
+              </a:rPr>
+              <a:t>(</a:t>
+            </a:r>
+            <a:r>
+              <a:rPr lang="pt-BR" b="0" dirty="0">
+                <a:solidFill>
+                  <a:srgbClr val="FD5FF0"/>
+                </a:solidFill>
+                <a:effectLst/>
+                <a:latin typeface="Consolas" panose="020B0609020204030204" pitchFamily="49" charset="0"/>
+              </a:rPr>
+              <a:t>:n3</a:t>
+            </a:r>
+            <a:r>
+              <a:rPr lang="pt-BR" b="0" dirty="0">
+                <a:solidFill>
+                  <a:srgbClr val="F8F8F0"/>
+                </a:solidFill>
+                <a:effectLst/>
+                <a:latin typeface="Consolas" panose="020B0609020204030204" pitchFamily="49" charset="0"/>
+              </a:rPr>
+              <a:t>, </a:t>
+            </a:r>
+            <a:r>
+              <a:rPr lang="pt-BR" b="0" dirty="0">
+                <a:solidFill>
+                  <a:srgbClr val="FD5FF0"/>
+                </a:solidFill>
+                <a:effectLst/>
+                <a:latin typeface="Consolas" panose="020B0609020204030204" pitchFamily="49" charset="0"/>
+              </a:rPr>
+              <a:t>:n1</a:t>
+            </a:r>
+            <a:r>
+              <a:rPr lang="pt-BR" b="0" dirty="0">
+                <a:solidFill>
+                  <a:srgbClr val="F8F8F0"/>
+                </a:solidFill>
+                <a:effectLst/>
+                <a:latin typeface="Consolas" panose="020B0609020204030204" pitchFamily="49" charset="0"/>
+              </a:rPr>
+              <a:t>, </a:t>
+            </a:r>
+            <a:r>
+              <a:rPr lang="pt-BR" b="0" dirty="0">
+                <a:solidFill>
+                  <a:srgbClr val="00AAFF"/>
+                </a:solidFill>
+                <a:effectLst/>
+                <a:latin typeface="Consolas" panose="020B0609020204030204" pitchFamily="49" charset="0"/>
+              </a:rPr>
+              <a:t>3000.0</a:t>
+            </a:r>
+            <a:r>
+              <a:rPr lang="pt-BR" b="0" dirty="0">
+                <a:solidFill>
+                  <a:srgbClr val="FF8F3F"/>
+                </a:solidFill>
+                <a:effectLst/>
+                <a:latin typeface="Consolas" panose="020B0609020204030204" pitchFamily="49" charset="0"/>
+              </a:rPr>
+              <a:t>)</a:t>
+            </a:r>
+            <a:r>
+              <a:rPr lang="pt-BR" b="0" dirty="0">
+                <a:solidFill>
+                  <a:srgbClr val="F8F8F0"/>
+                </a:solidFill>
+                <a:effectLst/>
+                <a:latin typeface="Consolas" panose="020B0609020204030204" pitchFamily="49" charset="0"/>
+              </a:rPr>
+              <a:t>    </a:t>
+            </a:r>
+            <a:r>
+              <a:rPr lang="pt-BR" b="0" i="1" dirty="0">
+                <a:solidFill>
+                  <a:srgbClr val="5C6370"/>
+                </a:solidFill>
+                <a:effectLst/>
+                <a:latin typeface="Consolas" panose="020B0609020204030204" pitchFamily="49" charset="0"/>
+              </a:rPr>
+              <a:t># ℓ₃₁   (B–A)</a:t>
+            </a:r>
+            <a:endParaRPr lang="pt-BR" b="0" dirty="0">
+              <a:solidFill>
+                <a:srgbClr val="F8F8F0"/>
+              </a:solidFill>
+              <a:effectLst/>
+              <a:latin typeface="Consolas" panose="020B0609020204030204" pitchFamily="49" charset="0"/>
+            </a:endParaRPr>
+          </a:p>
+          <a:p>
+            <a:pPr>
+              <a:lnSpc>
+                <a:spcPts val="1425"/>
+              </a:lnSpc>
+              <a:buNone/>
+            </a:pPr>
+            <a:r>
+              <a:rPr lang="pt-BR" b="0" dirty="0">
+                <a:solidFill>
+                  <a:srgbClr val="FF8F3F"/>
+                </a:solidFill>
+                <a:effectLst/>
+                <a:latin typeface="Consolas" panose="020B0609020204030204" pitchFamily="49" charset="0"/>
+              </a:rPr>
+              <a:t>]</a:t>
+            </a:r>
+            <a:endParaRPr lang="pt-BR" b="0" dirty="0">
+              <a:solidFill>
+                <a:srgbClr val="F8F8F0"/>
+              </a:solidFill>
+              <a:effectLst/>
+              <a:latin typeface="Consolas" panose="020B0609020204030204" pitchFamily="49" charset="0"/>
+            </a:endParaRPr>
+          </a:p>
+        </p:txBody>
+      </p:sp>
+      <p:sp>
+        <p:nvSpPr>
+          <p:cNvPr id="8" name="TextBox 7">
+            <a:extLst>
+              <a:ext uri="{FF2B5EF4-FFF2-40B4-BE49-F238E27FC236}">
+                <a16:creationId xmlns:a16="http://schemas.microsoft.com/office/drawing/2014/main" id="{0F586AEE-6F32-7F69-6B7D-7A444B1703B6}"/>
+              </a:ext>
+            </a:extLst>
+          </p:cNvPr>
+          <p:cNvSpPr txBox="1"/>
+          <p:nvPr/>
+        </p:nvSpPr>
+        <p:spPr>
+          <a:xfrm>
+            <a:off x="5049774" y="3685449"/>
+            <a:ext cx="4615434" cy="369332"/>
+          </a:xfrm>
+          <a:prstGeom prst="rect">
+            <a:avLst/>
+          </a:prstGeom>
+          <a:noFill/>
+        </p:spPr>
+        <p:txBody>
+          <a:bodyPr wrap="square">
+            <a:spAutoFit/>
+          </a:bodyPr>
+          <a:lstStyle/>
+          <a:p>
+            <a:r>
+              <a:rPr lang="pt-BR" b="0" dirty="0">
+                <a:solidFill>
+                  <a:srgbClr val="FF8F3F"/>
+                </a:solidFill>
+                <a:effectLst/>
+                <a:latin typeface="Consolas" panose="020B0609020204030204" pitchFamily="49" charset="0"/>
+              </a:rPr>
+              <a:t>Previously: (</a:t>
+            </a:r>
+            <a:r>
+              <a:rPr lang="pt-BR" b="0" dirty="0">
+                <a:solidFill>
+                  <a:srgbClr val="FD5FF0"/>
+                </a:solidFill>
+                <a:effectLst/>
+                <a:latin typeface="Consolas" panose="020B0609020204030204" pitchFamily="49" charset="0"/>
+              </a:rPr>
+              <a:t>:n1</a:t>
+            </a:r>
+            <a:r>
+              <a:rPr lang="pt-BR" b="0" dirty="0">
+                <a:solidFill>
+                  <a:srgbClr val="F8F8F0"/>
+                </a:solidFill>
+                <a:effectLst/>
+                <a:latin typeface="Consolas" panose="020B0609020204030204" pitchFamily="49" charset="0"/>
+              </a:rPr>
+              <a:t>, </a:t>
+            </a:r>
+            <a:r>
+              <a:rPr lang="pt-BR" b="0" dirty="0">
+                <a:solidFill>
+                  <a:srgbClr val="FD5FF0"/>
+                </a:solidFill>
+                <a:effectLst/>
+                <a:latin typeface="Consolas" panose="020B0609020204030204" pitchFamily="49" charset="0"/>
+              </a:rPr>
+              <a:t>:n2</a:t>
+            </a:r>
+            <a:r>
+              <a:rPr lang="pt-BR" b="0" dirty="0">
+                <a:solidFill>
+                  <a:srgbClr val="F8F8F0"/>
+                </a:solidFill>
+                <a:effectLst/>
+                <a:latin typeface="Consolas" panose="020B0609020204030204" pitchFamily="49" charset="0"/>
+              </a:rPr>
+              <a:t>, </a:t>
+            </a:r>
+            <a:r>
+              <a:rPr lang="pt-BR" b="0" dirty="0">
+                <a:solidFill>
+                  <a:srgbClr val="00AAFF"/>
+                </a:solidFill>
+                <a:effectLst/>
+                <a:latin typeface="Consolas" panose="020B0609020204030204" pitchFamily="49" charset="0"/>
+              </a:rPr>
+              <a:t>2000.0</a:t>
+            </a:r>
+            <a:r>
+              <a:rPr lang="pt-BR" b="0" dirty="0">
+                <a:solidFill>
+                  <a:srgbClr val="FF8F3F"/>
+                </a:solidFill>
+                <a:effectLst/>
+                <a:latin typeface="Consolas" panose="020B0609020204030204" pitchFamily="49" charset="0"/>
+              </a:rPr>
+              <a:t>)</a:t>
+            </a:r>
+            <a:r>
+              <a:rPr lang="pt-BR" b="0" dirty="0">
+                <a:solidFill>
+                  <a:srgbClr val="F8F8F0"/>
+                </a:solidFill>
+                <a:effectLst/>
+                <a:latin typeface="Consolas" panose="020B0609020204030204" pitchFamily="49" charset="0"/>
+              </a:rPr>
+              <a:t>,   </a:t>
             </a:r>
             <a:endParaRPr lang="nl-NL" dirty="0"/>
           </a:p>
@@ -3386,7 +4760,7 @@
     </p:spTree>
     <p:extLst>
       <p:ext uri="{BB962C8B-B14F-4D97-AF65-F5344CB8AC3E}">
-        <p14:creationId xmlns:p14="http://schemas.microsoft.com/office/powerpoint/2010/main" val="1668949742"/>
+        <p14:creationId xmlns:p14="http://schemas.microsoft.com/office/powerpoint/2010/main" val="3125131823"/>
       </p:ext>
     </p:extLst>
   </p:cSld>
@@ -3443,24 +4817,24 @@
         </p:spPr>
         <p:txBody>
           <a:bodyPr>
-            <a:normAutofit fontScale="92500" lnSpcReduction="10000"/>
+            <a:normAutofit fontScale="85000" lnSpcReduction="20000"/>
           </a:bodyPr>
           <a:lstStyle/>
           <a:p>
             <a:r>
-              <a:rPr lang="en-US" dirty="0"/>
-              <a:t>Installed capacity: capacity mix differs across both NTC &amp; FBMC designs</a:t>
-            </a:r>
-            <a:endParaRPr lang="nl-NL" dirty="0"/>
+              <a:rPr lang="en-US" sz="1800" dirty="0"/>
+              <a:t>Installed capacity: capacity mix differs across both NTC &amp; FBMC designs.  FBMC directs investments toward the cheaper zone A.</a:t>
+            </a:r>
+            <a:endParaRPr lang="nl-NL" sz="1800" dirty="0"/>
           </a:p>
         </p:txBody>
       </p:sp>
       <p:pic>
         <p:nvPicPr>
-          <p:cNvPr id="4" name="Picture 3" descr="A graph of different sizes of bars&#10;&#10;AI-generated content may be incorrect.">
-            <a:extLst>
-              <a:ext uri="{FF2B5EF4-FFF2-40B4-BE49-F238E27FC236}">
-                <a16:creationId xmlns:a16="http://schemas.microsoft.com/office/drawing/2014/main" id="{C157E5D8-4F05-455F-54B8-331423B5C35E}"/>
+          <p:cNvPr id="5" name="Picture 4">
+            <a:extLst>
+              <a:ext uri="{FF2B5EF4-FFF2-40B4-BE49-F238E27FC236}">
+                <a16:creationId xmlns:a16="http://schemas.microsoft.com/office/drawing/2014/main" id="{A8BC3733-77D9-2D4F-CDB7-3401259FED03}"/>
               </a:ext>
             </a:extLst>
           </p:cNvPr>
@@ -3470,15 +4844,15 @@
           <p:nvPr/>
         </p:nvPicPr>
         <p:blipFill>
-          <a:blip r:embed="rId2"/>
+          <a:blip r:embed="rId3"/>
           <a:stretch>
             <a:fillRect/>
           </a:stretch>
         </p:blipFill>
         <p:spPr>
           <a:xfrm>
-            <a:off x="560614" y="283890"/>
-            <a:ext cx="11070771" cy="5593127"/>
+            <a:off x="288758" y="339579"/>
+            <a:ext cx="10934299" cy="5524180"/>
           </a:xfrm>
           <a:prstGeom prst="rect">
             <a:avLst/>
@@ -3553,10 +4927,10 @@
       </p:sp>
       <p:pic>
         <p:nvPicPr>
-          <p:cNvPr id="5" name="Picture 4" descr="A graph with squares and numbers&#10;&#10;AI-generated content may be incorrect.">
-            <a:extLst>
-              <a:ext uri="{FF2B5EF4-FFF2-40B4-BE49-F238E27FC236}">
-                <a16:creationId xmlns:a16="http://schemas.microsoft.com/office/drawing/2014/main" id="{1ED01C93-C6F3-9188-6988-D62DA12A20B2}"/>
+          <p:cNvPr id="4" name="Picture 3">
+            <a:extLst>
+              <a:ext uri="{FF2B5EF4-FFF2-40B4-BE49-F238E27FC236}">
+                <a16:creationId xmlns:a16="http://schemas.microsoft.com/office/drawing/2014/main" id="{26E15B39-F353-941A-2D7D-EDA5B41801DC}"/>
               </a:ext>
             </a:extLst>
           </p:cNvPr>
@@ -3573,8 +4947,8 @@
         </p:blipFill>
         <p:spPr>
           <a:xfrm>
-            <a:off x="0" y="0"/>
-            <a:ext cx="12192000" cy="5888045"/>
+            <a:off x="404261" y="523478"/>
+            <a:ext cx="10281775" cy="4965515"/>
           </a:xfrm>
           <a:prstGeom prst="rect">
             <a:avLst/>
@@ -3595,6 +4969,291 @@
 </file>
 
 <file path=ppt/slides/slide4.xml><?xml version="1.0" encoding="utf-8"?>
+<p:sld xmlns:a="http://schemas.openxmlformats.org/drawingml/2006/main" xmlns:r="http://schemas.openxmlformats.org/officeDocument/2006/relationships" xmlns:p="http://schemas.openxmlformats.org/presentationml/2006/main">
+  <p:cSld>
+    <p:bg>
+      <p:bgPr>
+        <a:solidFill>
+          <a:schemeClr val="bg1"/>
+        </a:solidFill>
+        <a:effectLst/>
+      </p:bgPr>
+    </p:bg>
+    <p:spTree>
+      <p:nvGrpSpPr>
+        <p:cNvPr id="1" name="">
+          <a:extLst>
+            <a:ext uri="{FF2B5EF4-FFF2-40B4-BE49-F238E27FC236}">
+              <a16:creationId xmlns:a16="http://schemas.microsoft.com/office/drawing/2014/main" id="{ED6EB84F-0D30-675C-6850-07FB082FC516}"/>
+            </a:ext>
+          </a:extLst>
+        </p:cNvPr>
+        <p:cNvGrpSpPr/>
+        <p:nvPr/>
+      </p:nvGrpSpPr>
+      <p:grpSpPr>
+        <a:xfrm>
+          <a:off x="0" y="0"/>
+          <a:ext cx="0" cy="0"/>
+          <a:chOff x="0" y="0"/>
+          <a:chExt cx="0" cy="0"/>
+        </a:xfrm>
+      </p:grpSpPr>
+      <p:sp>
+        <p:nvSpPr>
+          <p:cNvPr id="3" name="Subtitle 2">
+            <a:extLst>
+              <a:ext uri="{FF2B5EF4-FFF2-40B4-BE49-F238E27FC236}">
+                <a16:creationId xmlns:a16="http://schemas.microsoft.com/office/drawing/2014/main" id="{585271E0-5983-95BC-08C1-FFF3BC17E5B5}"/>
+              </a:ext>
+            </a:extLst>
+          </p:cNvPr>
+          <p:cNvSpPr>
+            <a:spLocks noGrp="1"/>
+          </p:cNvSpPr>
+          <p:nvPr>
+            <p:ph type="subTitle" idx="1"/>
+          </p:nvPr>
+        </p:nvSpPr>
+        <p:spPr>
+          <a:xfrm>
+            <a:off x="3913632" y="5586258"/>
+            <a:ext cx="7440167" cy="804160"/>
+          </a:xfrm>
+        </p:spPr>
+        <p:txBody>
+          <a:bodyPr anchor="ctr">
+            <a:normAutofit/>
+          </a:bodyPr>
+          <a:lstStyle/>
+          <a:p>
+            <a:r>
+              <a:rPr lang="en-US" sz="1800" dirty="0"/>
+              <a:t>The overall capacity price is lower in FBMC than in NTC due to greater cross-border capacity trade.</a:t>
+            </a:r>
+            <a:endParaRPr lang="nl-NL" sz="1800" dirty="0"/>
+          </a:p>
+        </p:txBody>
+      </p:sp>
+      <p:grpSp>
+        <p:nvGrpSpPr>
+          <p:cNvPr id="10" name="Group 9">
+            <a:extLst>
+              <a:ext uri="{FF2B5EF4-FFF2-40B4-BE49-F238E27FC236}">
+                <a16:creationId xmlns:a16="http://schemas.microsoft.com/office/drawing/2014/main" id="{E68A7DB7-705D-1052-2293-363300E7A737}"/>
+              </a:ext>
+              <a:ext uri="{C183D7F6-B498-43B3-948B-1728B52AA6E4}">
+                <adec:decorative xmlns:adec="http://schemas.microsoft.com/office/drawing/2017/decorative" val="1"/>
+              </a:ext>
+            </a:extLst>
+          </p:cNvPr>
+          <p:cNvGrpSpPr>
+            <a:grpSpLocks noGrp="1" noUngrp="1" noRot="1" noChangeAspect="1" noMove="1" noResize="1"/>
+          </p:cNvGrpSpPr>
+          <p:nvPr>
+            <p:extLst>
+              <p:ext uri="{386F3935-93C4-4BCD-93E2-E3B085C9AB24}">
+                <p16:designElem xmlns:p16="http://schemas.microsoft.com/office/powerpoint/2015/main" val="1"/>
+              </p:ext>
+            </p:extLst>
+          </p:nvPr>
+        </p:nvGrpSpPr>
+        <p:grpSpPr>
+          <a:xfrm>
+            <a:off x="-5025" y="5193518"/>
+            <a:ext cx="12207200" cy="123363"/>
+            <a:chOff x="-5025" y="6737718"/>
+            <a:chExt cx="12207200" cy="123363"/>
+          </a:xfrm>
+        </p:grpSpPr>
+        <p:sp>
+          <p:nvSpPr>
+            <p:cNvPr id="11" name="Rectangle 10">
+              <a:extLst>
+                <a:ext uri="{FF2B5EF4-FFF2-40B4-BE49-F238E27FC236}">
+                  <a16:creationId xmlns:a16="http://schemas.microsoft.com/office/drawing/2014/main" id="{D671972D-10B6-F187-F466-9C4D5FB78E52}"/>
+                </a:ext>
+                <a:ext uri="{C183D7F6-B498-43B3-948B-1728B52AA6E4}">
+                  <adec:decorative xmlns:adec="http://schemas.microsoft.com/office/drawing/2017/decorative" val="1"/>
+                </a:ext>
+              </a:extLst>
+            </p:cNvPr>
+            <p:cNvSpPr/>
+            <p:nvPr>
+              <p:extLst>
+                <p:ext uri="{386F3935-93C4-4BCD-93E2-E3B085C9AB24}">
+                  <p16:designElem xmlns:p16="http://schemas.microsoft.com/office/powerpoint/2015/main" val="1"/>
+                </p:ext>
+              </p:extLst>
+            </p:nvPr>
+          </p:nvSpPr>
+          <p:spPr>
+            <a:xfrm rot="5400000" flipH="1">
+              <a:off x="6036894" y="695800"/>
+              <a:ext cx="123362" cy="12207199"/>
+            </a:xfrm>
+            <a:prstGeom prst="rect">
+              <a:avLst/>
+            </a:prstGeom>
+            <a:gradFill>
+              <a:gsLst>
+                <a:gs pos="0">
+                  <a:schemeClr val="accent5"/>
+                </a:gs>
+                <a:gs pos="100000">
+                  <a:schemeClr val="accent2"/>
+                </a:gs>
+              </a:gsLst>
+              <a:lin ang="1800000" scaled="0"/>
+            </a:gradFill>
+            <a:ln>
+              <a:noFill/>
+            </a:ln>
+          </p:spPr>
+          <p:style>
+            <a:lnRef idx="2">
+              <a:schemeClr val="accent1">
+                <a:shade val="50000"/>
+              </a:schemeClr>
+            </a:lnRef>
+            <a:fillRef idx="1">
+              <a:schemeClr val="accent1"/>
+            </a:fillRef>
+            <a:effectRef idx="0">
+              <a:schemeClr val="accent1"/>
+            </a:effectRef>
+            <a:fontRef idx="minor">
+              <a:schemeClr val="lt1"/>
+            </a:fontRef>
+          </p:style>
+          <p:txBody>
+            <a:bodyPr rtlCol="0" anchor="ctr"/>
+            <a:lstStyle/>
+            <a:p>
+              <a:pPr algn="ctr"/>
+              <a:endParaRPr lang="en-US"/>
+            </a:p>
+          </p:txBody>
+        </p:sp>
+        <p:sp>
+          <p:nvSpPr>
+            <p:cNvPr id="12" name="Rectangle 11">
+              <a:extLst>
+                <a:ext uri="{FF2B5EF4-FFF2-40B4-BE49-F238E27FC236}">
+                  <a16:creationId xmlns:a16="http://schemas.microsoft.com/office/drawing/2014/main" id="{783E23D8-B7D0-A376-89DC-7AE807D386FF}"/>
+                </a:ext>
+                <a:ext uri="{C183D7F6-B498-43B3-948B-1728B52AA6E4}">
+                  <adec:decorative xmlns:adec="http://schemas.microsoft.com/office/drawing/2017/decorative" val="1"/>
+                </a:ext>
+              </a:extLst>
+            </p:cNvPr>
+            <p:cNvSpPr/>
+            <p:nvPr>
+              <p:extLst>
+                <p:ext uri="{386F3935-93C4-4BCD-93E2-E3B085C9AB24}">
+                  <p16:designElem xmlns:p16="http://schemas.microsoft.com/office/powerpoint/2015/main" val="1"/>
+                </p:ext>
+              </p:extLst>
+            </p:nvPr>
+          </p:nvSpPr>
+          <p:spPr>
+            <a:xfrm rot="16200000">
+              <a:off x="9176406" y="3835311"/>
+              <a:ext cx="123362" cy="5928176"/>
+            </a:xfrm>
+            <a:prstGeom prst="rect">
+              <a:avLst/>
+            </a:prstGeom>
+            <a:gradFill>
+              <a:gsLst>
+                <a:gs pos="19000">
+                  <a:schemeClr val="accent5">
+                    <a:alpha val="0"/>
+                  </a:schemeClr>
+                </a:gs>
+                <a:gs pos="100000">
+                  <a:schemeClr val="accent5">
+                    <a:lumMod val="60000"/>
+                    <a:lumOff val="40000"/>
+                  </a:schemeClr>
+                </a:gs>
+              </a:gsLst>
+              <a:lin ang="600000" scaled="0"/>
+            </a:gradFill>
+            <a:ln>
+              <a:noFill/>
+            </a:ln>
+          </p:spPr>
+          <p:style>
+            <a:lnRef idx="2">
+              <a:schemeClr val="accent1">
+                <a:shade val="50000"/>
+              </a:schemeClr>
+            </a:lnRef>
+            <a:fillRef idx="1">
+              <a:schemeClr val="accent1"/>
+            </a:fillRef>
+            <a:effectRef idx="0">
+              <a:schemeClr val="accent1"/>
+            </a:effectRef>
+            <a:fontRef idx="minor">
+              <a:schemeClr val="lt1"/>
+            </a:fontRef>
+          </p:style>
+          <p:txBody>
+            <a:bodyPr rtlCol="0" anchor="ctr"/>
+            <a:lstStyle/>
+            <a:p>
+              <a:pPr algn="ctr"/>
+              <a:endParaRPr lang="en-US"/>
+            </a:p>
+          </p:txBody>
+        </p:sp>
+      </p:grpSp>
+      <p:pic>
+        <p:nvPicPr>
+          <p:cNvPr id="8" name="Picture 7">
+            <a:extLst>
+              <a:ext uri="{FF2B5EF4-FFF2-40B4-BE49-F238E27FC236}">
+                <a16:creationId xmlns:a16="http://schemas.microsoft.com/office/drawing/2014/main" id="{CC7EB043-6788-5F60-23E8-0BC3720B50D3}"/>
+              </a:ext>
+            </a:extLst>
+          </p:cNvPr>
+          <p:cNvPicPr>
+            <a:picLocks noChangeAspect="1"/>
+          </p:cNvPicPr>
+          <p:nvPr/>
+        </p:nvPicPr>
+        <p:blipFill>
+          <a:blip r:embed="rId2"/>
+          <a:stretch>
+            <a:fillRect/>
+          </a:stretch>
+        </p:blipFill>
+        <p:spPr>
+          <a:xfrm>
+            <a:off x="0" y="0"/>
+            <a:ext cx="11223057" cy="5407444"/>
+          </a:xfrm>
+          <a:prstGeom prst="rect">
+            <a:avLst/>
+          </a:prstGeom>
+        </p:spPr>
+      </p:pic>
+    </p:spTree>
+    <p:extLst>
+      <p:ext uri="{BB962C8B-B14F-4D97-AF65-F5344CB8AC3E}">
+        <p14:creationId xmlns:p14="http://schemas.microsoft.com/office/powerpoint/2010/main" val="822520436"/>
+      </p:ext>
+    </p:extLst>
+  </p:cSld>
+  <p:clrMapOvr>
+    <a:masterClrMapping/>
+  </p:clrMapOvr>
+</p:sld>
+</file>
+
+<file path=ppt/slides/slide5.xml><?xml version="1.0" encoding="utf-8"?>
 <p:sld xmlns:a="http://schemas.openxmlformats.org/drawingml/2006/main" xmlns:r="http://schemas.openxmlformats.org/officeDocument/2006/relationships" xmlns:p="http://schemas.openxmlformats.org/presentationml/2006/main">
   <p:cSld>
     <p:bg>
@@ -3735,12 +5394,50 @@
           </a:fontRef>
         </p:style>
       </p:cxnSp>
+      <p:sp>
+        <p:nvSpPr>
+          <p:cNvPr id="3" name="Subtitle 2">
+            <a:extLst>
+              <a:ext uri="{FF2B5EF4-FFF2-40B4-BE49-F238E27FC236}">
+                <a16:creationId xmlns:a16="http://schemas.microsoft.com/office/drawing/2014/main" id="{0B974838-2B6F-8D90-6210-14650B86D166}"/>
+              </a:ext>
+            </a:extLst>
+          </p:cNvPr>
+          <p:cNvSpPr>
+            <a:spLocks noGrp="1"/>
+          </p:cNvSpPr>
+          <p:nvPr>
+            <p:ph type="subTitle" idx="1"/>
+          </p:nvPr>
+        </p:nvSpPr>
+        <p:spPr>
+          <a:xfrm>
+            <a:off x="141511" y="6046106"/>
+            <a:ext cx="11416504" cy="660294"/>
+          </a:xfrm>
+          <a:noFill/>
+        </p:spPr>
+        <p:txBody>
+          <a:bodyPr anchor="ctr">
+            <a:normAutofit/>
+          </a:bodyPr>
+          <a:lstStyle/>
+          <a:p>
+            <a:pPr algn="l"/>
+            <a:r>
+              <a:rPr lang="en-US" dirty="0"/>
+              <a:t>Cost to consumers: costs remain the same across FBMC and NTC.</a:t>
+            </a:r>
+            <a:endParaRPr lang="nl-NL" dirty="0"/>
+          </a:p>
+        </p:txBody>
+      </p:sp>
       <p:pic>
         <p:nvPicPr>
-          <p:cNvPr id="7" name="Picture 6" descr="A graph of different colored bars&#10;&#10;AI-generated content may be incorrect.">
-            <a:extLst>
-              <a:ext uri="{FF2B5EF4-FFF2-40B4-BE49-F238E27FC236}">
-                <a16:creationId xmlns:a16="http://schemas.microsoft.com/office/drawing/2014/main" id="{C5C94442-B17C-6E70-8C99-0F88A6D4CBB0}"/>
+          <p:cNvPr id="4" name="Picture 3">
+            <a:extLst>
+              <a:ext uri="{FF2B5EF4-FFF2-40B4-BE49-F238E27FC236}">
+                <a16:creationId xmlns:a16="http://schemas.microsoft.com/office/drawing/2014/main" id="{5BB100FD-EC2A-D1B5-AA9C-346F6B4A5339}"/>
               </a:ext>
             </a:extLst>
           </p:cNvPr>
@@ -3757,52 +5454,14 @@
         </p:blipFill>
         <p:spPr>
           <a:xfrm>
-            <a:off x="-3049" y="161705"/>
-            <a:ext cx="12192000" cy="5874296"/>
+            <a:off x="575119" y="432151"/>
+            <a:ext cx="11343662" cy="5462355"/>
           </a:xfrm>
           <a:prstGeom prst="rect">
             <a:avLst/>
           </a:prstGeom>
         </p:spPr>
       </p:pic>
-      <p:sp>
-        <p:nvSpPr>
-          <p:cNvPr id="3" name="Subtitle 2">
-            <a:extLst>
-              <a:ext uri="{FF2B5EF4-FFF2-40B4-BE49-F238E27FC236}">
-                <a16:creationId xmlns:a16="http://schemas.microsoft.com/office/drawing/2014/main" id="{0B974838-2B6F-8D90-6210-14650B86D166}"/>
-              </a:ext>
-            </a:extLst>
-          </p:cNvPr>
-          <p:cNvSpPr>
-            <a:spLocks noGrp="1"/>
-          </p:cNvSpPr>
-          <p:nvPr>
-            <p:ph type="subTitle" idx="1"/>
-          </p:nvPr>
-        </p:nvSpPr>
-        <p:spPr>
-          <a:xfrm>
-            <a:off x="141511" y="6046106"/>
-            <a:ext cx="11416504" cy="660294"/>
-          </a:xfrm>
-          <a:noFill/>
-        </p:spPr>
-        <p:txBody>
-          <a:bodyPr anchor="ctr">
-            <a:normAutofit fontScale="92500" lnSpcReduction="10000"/>
-          </a:bodyPr>
-          <a:lstStyle/>
-          <a:p>
-            <a:pPr algn="l"/>
-            <a:r>
-              <a:rPr lang="en-US" dirty="0"/>
-              <a:t>Cost to consumers: costs remain the same across FBMC and NTC because investment and operational costs are the same across the system</a:t>
-            </a:r>
-            <a:endParaRPr lang="nl-NL" dirty="0"/>
-          </a:p>
-        </p:txBody>
-      </p:sp>
     </p:spTree>
     <p:extLst>
       <p:ext uri="{BB962C8B-B14F-4D97-AF65-F5344CB8AC3E}">
@@ -3816,7 +5475,7 @@
 </p:sld>
 </file>
 
-<file path=ppt/slides/slide5.xml><?xml version="1.0" encoding="utf-8"?>
+<file path=ppt/slides/slide6.xml><?xml version="1.0" encoding="utf-8"?>
 <p:sld xmlns:a="http://schemas.openxmlformats.org/drawingml/2006/main" xmlns:r="http://schemas.openxmlformats.org/officeDocument/2006/relationships" xmlns:p="http://schemas.openxmlformats.org/presentationml/2006/main">
   <p:cSld>
     <p:bg>
@@ -3847,39 +5506,36 @@
           <a:chExt cx="0" cy="0"/>
         </a:xfrm>
       </p:grpSpPr>
-      <p:sp>
-        <p:nvSpPr>
-          <p:cNvPr id="3" name="Subtitle 2">
-            <a:extLst>
-              <a:ext uri="{FF2B5EF4-FFF2-40B4-BE49-F238E27FC236}">
-                <a16:creationId xmlns:a16="http://schemas.microsoft.com/office/drawing/2014/main" id="{983C0F5F-9CB0-B382-559A-98064620E510}"/>
-              </a:ext>
-            </a:extLst>
-          </p:cNvPr>
-          <p:cNvSpPr>
-            <a:spLocks noGrp="1"/>
-          </p:cNvSpPr>
-          <p:nvPr>
-            <p:ph type="subTitle" idx="1"/>
-          </p:nvPr>
-        </p:nvSpPr>
+      <p:pic>
+        <p:nvPicPr>
+          <p:cNvPr id="8" name="Picture 7">
+            <a:extLst>
+              <a:ext uri="{FF2B5EF4-FFF2-40B4-BE49-F238E27FC236}">
+                <a16:creationId xmlns:a16="http://schemas.microsoft.com/office/drawing/2014/main" id="{5EA9B93B-8CC5-5E94-138A-207F4F1F2F7C}"/>
+              </a:ext>
+            </a:extLst>
+          </p:cNvPr>
+          <p:cNvPicPr>
+            <a:picLocks noChangeAspect="1"/>
+          </p:cNvPicPr>
+          <p:nvPr/>
+        </p:nvPicPr>
+        <p:blipFill>
+          <a:blip r:embed="rId2"/>
+          <a:stretch>
+            <a:fillRect/>
+          </a:stretch>
+        </p:blipFill>
         <p:spPr>
           <a:xfrm>
-            <a:off x="7764904" y="5586258"/>
-            <a:ext cx="3588895" cy="804160"/>
+            <a:off x="0" y="24383"/>
+            <a:ext cx="12192000" cy="6809234"/>
           </a:xfrm>
+          <a:prstGeom prst="rect">
+            <a:avLst/>
+          </a:prstGeom>
         </p:spPr>
-        <p:txBody>
-          <a:bodyPr anchor="ctr">
-            <a:normAutofit/>
-          </a:bodyPr>
-          <a:lstStyle/>
-          <a:p>
-            <a:pPr algn="r"/>
-            <a:endParaRPr lang="nl-NL" sz="1800"/>
-          </a:p>
-        </p:txBody>
-      </p:sp>
+      </p:pic>
       <p:grpSp>
         <p:nvGrpSpPr>
           <p:cNvPr id="10" name="Group 9">
@@ -4055,55 +5711,25 @@
           </p:txBody>
         </p:sp>
       </p:grpSp>
-      <p:pic>
-        <p:nvPicPr>
-          <p:cNvPr id="6" name="Picture 5" descr="A graph of a number of bars&#10;&#10;AI-generated content may be incorrect.">
-            <a:extLst>
-              <a:ext uri="{FF2B5EF4-FFF2-40B4-BE49-F238E27FC236}">
-                <a16:creationId xmlns:a16="http://schemas.microsoft.com/office/drawing/2014/main" id="{85C39101-867A-6260-305E-AF7104EA42C1}"/>
-              </a:ext>
-            </a:extLst>
-          </p:cNvPr>
-          <p:cNvPicPr>
-            <a:picLocks noChangeAspect="1"/>
-          </p:cNvPicPr>
-          <p:nvPr/>
-        </p:nvPicPr>
-        <p:blipFill>
-          <a:blip r:embed="rId2"/>
-          <a:stretch>
-            <a:fillRect/>
-          </a:stretch>
-        </p:blipFill>
+      <p:sp>
+        <p:nvSpPr>
+          <p:cNvPr id="2" name="Title 1">
+            <a:extLst>
+              <a:ext uri="{FF2B5EF4-FFF2-40B4-BE49-F238E27FC236}">
+                <a16:creationId xmlns:a16="http://schemas.microsoft.com/office/drawing/2014/main" id="{652912CA-A241-3C64-DB97-5297B88DD8FA}"/>
+              </a:ext>
+            </a:extLst>
+          </p:cNvPr>
+          <p:cNvSpPr>
+            <a:spLocks noGrp="1"/>
+          </p:cNvSpPr>
+          <p:nvPr>
+            <p:ph type="ctrTitle"/>
+          </p:nvPr>
+        </p:nvSpPr>
         <p:spPr>
           <a:xfrm>
-            <a:off x="319168" y="0"/>
-            <a:ext cx="11713030" cy="6541729"/>
-          </a:xfrm>
-          <a:prstGeom prst="rect">
-            <a:avLst/>
-          </a:prstGeom>
-        </p:spPr>
-      </p:pic>
-      <p:sp>
-        <p:nvSpPr>
-          <p:cNvPr id="2" name="Title 1">
-            <a:extLst>
-              <a:ext uri="{FF2B5EF4-FFF2-40B4-BE49-F238E27FC236}">
-                <a16:creationId xmlns:a16="http://schemas.microsoft.com/office/drawing/2014/main" id="{652912CA-A241-3C64-DB97-5297B88DD8FA}"/>
-              </a:ext>
-            </a:extLst>
-          </p:cNvPr>
-          <p:cNvSpPr>
-            <a:spLocks noGrp="1"/>
-          </p:cNvSpPr>
-          <p:nvPr>
-            <p:ph type="ctrTitle"/>
-          </p:nvPr>
-        </p:nvSpPr>
-        <p:spPr>
-          <a:xfrm>
-            <a:off x="1161310" y="1792598"/>
+            <a:off x="4193267" y="3852588"/>
             <a:ext cx="7735802" cy="804161"/>
           </a:xfrm>
         </p:spPr>
@@ -4116,7 +5742,7 @@
             <a:pPr algn="l"/>
             <a:r>
               <a:rPr lang="en-US" sz="3200" dirty="0"/>
-              <a:t>System costs: same for both FBMC and NTC since costs are the same across zones</a:t>
+              <a:t>System costs: Slightly higher system costs  for NTC w.r.t FBMC </a:t>
             </a:r>
             <a:endParaRPr lang="nl-NL" sz="3200" dirty="0"/>
           </a:p>
@@ -4135,7 +5761,300 @@
 </p:sld>
 </file>
 
-<file path=ppt/slides/slide6.xml><?xml version="1.0" encoding="utf-8"?>
+<file path=ppt/slides/slide7.xml><?xml version="1.0" encoding="utf-8"?>
+<p:sld xmlns:a="http://schemas.openxmlformats.org/drawingml/2006/main" xmlns:r="http://schemas.openxmlformats.org/officeDocument/2006/relationships" xmlns:p="http://schemas.openxmlformats.org/presentationml/2006/main">
+  <p:cSld>
+    <p:bg>
+      <p:bgPr>
+        <a:solidFill>
+          <a:schemeClr val="bg1"/>
+        </a:solidFill>
+        <a:effectLst/>
+      </p:bgPr>
+    </p:bg>
+    <p:spTree>
+      <p:nvGrpSpPr>
+        <p:cNvPr id="1" name="">
+          <a:extLst>
+            <a:ext uri="{FF2B5EF4-FFF2-40B4-BE49-F238E27FC236}">
+              <a16:creationId xmlns:a16="http://schemas.microsoft.com/office/drawing/2014/main" id="{2A5542FF-89B9-C9A6-3E62-0FADC677BC51}"/>
+            </a:ext>
+          </a:extLst>
+        </p:cNvPr>
+        <p:cNvGrpSpPr/>
+        <p:nvPr/>
+      </p:nvGrpSpPr>
+      <p:grpSpPr>
+        <a:xfrm>
+          <a:off x="0" y="0"/>
+          <a:ext cx="0" cy="0"/>
+          <a:chOff x="0" y="0"/>
+          <a:chExt cx="0" cy="0"/>
+        </a:xfrm>
+      </p:grpSpPr>
+      <p:sp>
+        <p:nvSpPr>
+          <p:cNvPr id="3" name="Subtitle 2">
+            <a:extLst>
+              <a:ext uri="{FF2B5EF4-FFF2-40B4-BE49-F238E27FC236}">
+                <a16:creationId xmlns:a16="http://schemas.microsoft.com/office/drawing/2014/main" id="{DD9AA3C7-EFA5-2E76-FFC3-5B7D14AE7385}"/>
+              </a:ext>
+            </a:extLst>
+          </p:cNvPr>
+          <p:cNvSpPr>
+            <a:spLocks noGrp="1"/>
+          </p:cNvSpPr>
+          <p:nvPr>
+            <p:ph type="subTitle" idx="1"/>
+          </p:nvPr>
+        </p:nvSpPr>
+        <p:spPr>
+          <a:xfrm>
+            <a:off x="3590224" y="5576632"/>
+            <a:ext cx="8422105" cy="1148379"/>
+          </a:xfrm>
+        </p:spPr>
+        <p:txBody>
+          <a:bodyPr anchor="ctr">
+            <a:normAutofit/>
+          </a:bodyPr>
+          <a:lstStyle/>
+          <a:p>
+            <a:r>
+              <a:rPr lang="en-US" sz="1800" dirty="0"/>
+              <a:t>Greater congestion rent captured in cm-</a:t>
+            </a:r>
+            <a:r>
+              <a:rPr lang="en-US" sz="1800" dirty="0" err="1"/>
+              <a:t>fbmc</a:t>
+            </a:r>
+            <a:r>
+              <a:rPr lang="en-US" sz="1800" dirty="0"/>
+              <a:t>. The welfare gain does not transfer to consumers but is captured by the network operator, who can then redistribute as they choose.</a:t>
+            </a:r>
+            <a:endParaRPr lang="nl-NL" sz="1800" dirty="0"/>
+          </a:p>
+        </p:txBody>
+      </p:sp>
+      <p:grpSp>
+        <p:nvGrpSpPr>
+          <p:cNvPr id="10" name="Group 9">
+            <a:extLst>
+              <a:ext uri="{FF2B5EF4-FFF2-40B4-BE49-F238E27FC236}">
+                <a16:creationId xmlns:a16="http://schemas.microsoft.com/office/drawing/2014/main" id="{075B2032-2CC9-E65F-8476-BD91E8E11416}"/>
+              </a:ext>
+              <a:ext uri="{C183D7F6-B498-43B3-948B-1728B52AA6E4}">
+                <adec:decorative xmlns:adec="http://schemas.microsoft.com/office/drawing/2017/decorative" val="1"/>
+              </a:ext>
+            </a:extLst>
+          </p:cNvPr>
+          <p:cNvGrpSpPr>
+            <a:grpSpLocks noGrp="1" noUngrp="1" noRot="1" noChangeAspect="1" noMove="1" noResize="1"/>
+          </p:cNvGrpSpPr>
+          <p:nvPr>
+            <p:extLst>
+              <p:ext uri="{386F3935-93C4-4BCD-93E2-E3B085C9AB24}">
+                <p16:designElem xmlns:p16="http://schemas.microsoft.com/office/powerpoint/2015/main" val="1"/>
+              </p:ext>
+            </p:extLst>
+          </p:nvPr>
+        </p:nvGrpSpPr>
+        <p:grpSpPr>
+          <a:xfrm>
+            <a:off x="-5025" y="5193518"/>
+            <a:ext cx="12207200" cy="123363"/>
+            <a:chOff x="-5025" y="6737718"/>
+            <a:chExt cx="12207200" cy="123363"/>
+          </a:xfrm>
+        </p:grpSpPr>
+        <p:sp>
+          <p:nvSpPr>
+            <p:cNvPr id="11" name="Rectangle 10">
+              <a:extLst>
+                <a:ext uri="{FF2B5EF4-FFF2-40B4-BE49-F238E27FC236}">
+                  <a16:creationId xmlns:a16="http://schemas.microsoft.com/office/drawing/2014/main" id="{288637CE-7A4E-FD78-3A8F-268CEB23DBA3}"/>
+                </a:ext>
+                <a:ext uri="{C183D7F6-B498-43B3-948B-1728B52AA6E4}">
+                  <adec:decorative xmlns:adec="http://schemas.microsoft.com/office/drawing/2017/decorative" val="1"/>
+                </a:ext>
+              </a:extLst>
+            </p:cNvPr>
+            <p:cNvSpPr/>
+            <p:nvPr>
+              <p:extLst>
+                <p:ext uri="{386F3935-93C4-4BCD-93E2-E3B085C9AB24}">
+                  <p16:designElem xmlns:p16="http://schemas.microsoft.com/office/powerpoint/2015/main" val="1"/>
+                </p:ext>
+              </p:extLst>
+            </p:nvPr>
+          </p:nvSpPr>
+          <p:spPr>
+            <a:xfrm rot="5400000" flipH="1">
+              <a:off x="6036894" y="695800"/>
+              <a:ext cx="123362" cy="12207199"/>
+            </a:xfrm>
+            <a:prstGeom prst="rect">
+              <a:avLst/>
+            </a:prstGeom>
+            <a:gradFill>
+              <a:gsLst>
+                <a:gs pos="0">
+                  <a:schemeClr val="accent5"/>
+                </a:gs>
+                <a:gs pos="100000">
+                  <a:schemeClr val="accent2"/>
+                </a:gs>
+              </a:gsLst>
+              <a:lin ang="1800000" scaled="0"/>
+            </a:gradFill>
+            <a:ln>
+              <a:noFill/>
+            </a:ln>
+          </p:spPr>
+          <p:style>
+            <a:lnRef idx="2">
+              <a:schemeClr val="accent1">
+                <a:shade val="50000"/>
+              </a:schemeClr>
+            </a:lnRef>
+            <a:fillRef idx="1">
+              <a:schemeClr val="accent1"/>
+            </a:fillRef>
+            <a:effectRef idx="0">
+              <a:schemeClr val="accent1"/>
+            </a:effectRef>
+            <a:fontRef idx="minor">
+              <a:schemeClr val="lt1"/>
+            </a:fontRef>
+          </p:style>
+          <p:txBody>
+            <a:bodyPr rtlCol="0" anchor="ctr"/>
+            <a:lstStyle/>
+            <a:p>
+              <a:pPr algn="ctr"/>
+              <a:endParaRPr lang="en-US"/>
+            </a:p>
+          </p:txBody>
+        </p:sp>
+        <p:sp>
+          <p:nvSpPr>
+            <p:cNvPr id="12" name="Rectangle 11">
+              <a:extLst>
+                <a:ext uri="{FF2B5EF4-FFF2-40B4-BE49-F238E27FC236}">
+                  <a16:creationId xmlns:a16="http://schemas.microsoft.com/office/drawing/2014/main" id="{549414F5-CC43-125A-D416-66476880336B}"/>
+                </a:ext>
+                <a:ext uri="{C183D7F6-B498-43B3-948B-1728B52AA6E4}">
+                  <adec:decorative xmlns:adec="http://schemas.microsoft.com/office/drawing/2017/decorative" val="1"/>
+                </a:ext>
+              </a:extLst>
+            </p:cNvPr>
+            <p:cNvSpPr/>
+            <p:nvPr>
+              <p:extLst>
+                <p:ext uri="{386F3935-93C4-4BCD-93E2-E3B085C9AB24}">
+                  <p16:designElem xmlns:p16="http://schemas.microsoft.com/office/powerpoint/2015/main" val="1"/>
+                </p:ext>
+              </p:extLst>
+            </p:nvPr>
+          </p:nvSpPr>
+          <p:spPr>
+            <a:xfrm rot="16200000">
+              <a:off x="9176406" y="3835311"/>
+              <a:ext cx="123362" cy="5928176"/>
+            </a:xfrm>
+            <a:prstGeom prst="rect">
+              <a:avLst/>
+            </a:prstGeom>
+            <a:gradFill>
+              <a:gsLst>
+                <a:gs pos="19000">
+                  <a:schemeClr val="accent5">
+                    <a:alpha val="0"/>
+                  </a:schemeClr>
+                </a:gs>
+                <a:gs pos="100000">
+                  <a:schemeClr val="accent5">
+                    <a:lumMod val="60000"/>
+                    <a:lumOff val="40000"/>
+                  </a:schemeClr>
+                </a:gs>
+              </a:gsLst>
+              <a:lin ang="600000" scaled="0"/>
+            </a:gradFill>
+            <a:ln>
+              <a:noFill/>
+            </a:ln>
+          </p:spPr>
+          <p:style>
+            <a:lnRef idx="2">
+              <a:schemeClr val="accent1">
+                <a:shade val="50000"/>
+              </a:schemeClr>
+            </a:lnRef>
+            <a:fillRef idx="1">
+              <a:schemeClr val="accent1"/>
+            </a:fillRef>
+            <a:effectRef idx="0">
+              <a:schemeClr val="accent1"/>
+            </a:effectRef>
+            <a:fontRef idx="minor">
+              <a:schemeClr val="lt1"/>
+            </a:fontRef>
+          </p:style>
+          <p:txBody>
+            <a:bodyPr rtlCol="0" anchor="ctr"/>
+            <a:lstStyle/>
+            <a:p>
+              <a:pPr algn="ctr"/>
+              <a:endParaRPr lang="en-US"/>
+            </a:p>
+          </p:txBody>
+        </p:sp>
+      </p:grpSp>
+      <p:pic>
+        <p:nvPicPr>
+          <p:cNvPr id="6" name="Picture 5">
+            <a:extLst>
+              <a:ext uri="{FF2B5EF4-FFF2-40B4-BE49-F238E27FC236}">
+                <a16:creationId xmlns:a16="http://schemas.microsoft.com/office/drawing/2014/main" id="{986A087C-5D24-49C8-DBBA-DE6C56DD13B7}"/>
+              </a:ext>
+            </a:extLst>
+          </p:cNvPr>
+          <p:cNvPicPr>
+            <a:picLocks noChangeAspect="1"/>
+          </p:cNvPicPr>
+          <p:nvPr/>
+        </p:nvPicPr>
+        <p:blipFill>
+          <a:blip r:embed="rId3"/>
+          <a:stretch>
+            <a:fillRect/>
+          </a:stretch>
+        </p:blipFill>
+        <p:spPr>
+          <a:xfrm>
+            <a:off x="798897" y="296667"/>
+            <a:ext cx="10456421" cy="5150089"/>
+          </a:xfrm>
+          <a:prstGeom prst="rect">
+            <a:avLst/>
+          </a:prstGeom>
+        </p:spPr>
+      </p:pic>
+    </p:spTree>
+    <p:extLst>
+      <p:ext uri="{BB962C8B-B14F-4D97-AF65-F5344CB8AC3E}">
+        <p14:creationId xmlns:p14="http://schemas.microsoft.com/office/powerpoint/2010/main" val="463208877"/>
+      </p:ext>
+    </p:extLst>
+  </p:cSld>
+  <p:clrMapOvr>
+    <a:masterClrMapping/>
+  </p:clrMapOvr>
+</p:sld>
+</file>
+
+<file path=ppt/slides/slide8.xml><?xml version="1.0" encoding="utf-8"?>
 <p:sld xmlns:a="http://schemas.openxmlformats.org/drawingml/2006/main" xmlns:r="http://schemas.openxmlformats.org/officeDocument/2006/relationships" xmlns:p="http://schemas.openxmlformats.org/presentationml/2006/main">
   <p:cSld>
     <p:spTree>
@@ -4182,14 +6101,14 @@
         </p:spPr>
         <p:txBody>
           <a:bodyPr>
-            <a:normAutofit fontScale="90000"/>
+            <a:normAutofit/>
           </a:bodyPr>
           <a:lstStyle/>
           <a:p>
             <a:pPr algn="ctr"/>
             <a:r>
               <a:rPr lang="en-US" dirty="0"/>
-              <a:t>Installed capacity differs across zones, with FBMC capturing more trade. However, since costs are the same across zones, it does not lead to a reduced cost. If costs were to differ across zones, then, the cross-border trade will lead to lower consumer costs</a:t>
+              <a:t>Installed capacity differs across zones, with FBMC capturing more trade. The cost implications are small because imports remain a small fraction of total investments.</a:t>
             </a:r>
             <a:endParaRPr lang="nl-NL" dirty="0"/>
           </a:p>
@@ -4208,7 +6127,7 @@
 </p:sld>
 </file>
 
-<file path=ppt/slides/slide7.xml><?xml version="1.0" encoding="utf-8"?>
+<file path=ppt/slides/slide9.xml><?xml version="1.0" encoding="utf-8"?>
 <p:sld xmlns:a="http://schemas.openxmlformats.org/drawingml/2006/main" xmlns:r="http://schemas.openxmlformats.org/officeDocument/2006/relationships" xmlns:p="http://schemas.openxmlformats.org/presentationml/2006/main">
   <p:cSld>
     <p:spTree>
@@ -4216,7 +6135,7 @@
         <p:cNvPr id="1" name="">
           <a:extLst>
             <a:ext uri="{FF2B5EF4-FFF2-40B4-BE49-F238E27FC236}">
-              <a16:creationId xmlns:a16="http://schemas.microsoft.com/office/drawing/2014/main" id="{59B449D0-6866-447D-8232-865D86112898}"/>
+              <a16:creationId xmlns:a16="http://schemas.microsoft.com/office/drawing/2014/main" id="{7BE55682-9757-C900-9E96-AB181267C333}"/>
             </a:ext>
           </a:extLst>
         </p:cNvPr>
@@ -4236,7 +6155,7 @@
           <p:cNvPr id="2" name="Title 1">
             <a:extLst>
               <a:ext uri="{FF2B5EF4-FFF2-40B4-BE49-F238E27FC236}">
-                <a16:creationId xmlns:a16="http://schemas.microsoft.com/office/drawing/2014/main" id="{7C6DC122-5263-0A87-E6A5-529310AD7C04}"/>
+                <a16:creationId xmlns:a16="http://schemas.microsoft.com/office/drawing/2014/main" id="{219263D0-02C6-22F6-6582-BD6BB51F5C26}"/>
               </a:ext>
             </a:extLst>
           </p:cNvPr>
@@ -4254,13 +6173,101 @@
           </a:xfrm>
         </p:spPr>
         <p:txBody>
-          <a:bodyPr/>
+          <a:bodyPr>
+            <a:normAutofit/>
+          </a:bodyPr>
           <a:lstStyle/>
           <a:p>
             <a:pPr algn="ctr"/>
             <a:r>
               <a:rPr lang="en-US" dirty="0"/>
-              <a:t>When all costs differ across zones</a:t>
+              <a:t>When investment costs of peak unit differ across zones</a:t>
+            </a:r>
+            <a:endParaRPr lang="nl-NL" dirty="0"/>
+          </a:p>
+        </p:txBody>
+      </p:sp>
+      <p:sp>
+        <p:nvSpPr>
+          <p:cNvPr id="4" name="TextBox 3">
+            <a:extLst>
+              <a:ext uri="{FF2B5EF4-FFF2-40B4-BE49-F238E27FC236}">
+                <a16:creationId xmlns:a16="http://schemas.microsoft.com/office/drawing/2014/main" id="{6AA84856-9902-F268-2771-3EE5278F3B80}"/>
+              </a:ext>
+            </a:extLst>
+          </p:cNvPr>
+          <p:cNvSpPr txBox="1"/>
+          <p:nvPr/>
+        </p:nvSpPr>
+        <p:spPr>
+          <a:xfrm>
+            <a:off x="1757934" y="4387335"/>
+            <a:ext cx="2009394" cy="1200329"/>
+          </a:xfrm>
+          <a:prstGeom prst="rect">
+            <a:avLst/>
+          </a:prstGeom>
+          <a:noFill/>
+        </p:spPr>
+        <p:txBody>
+          <a:bodyPr wrap="square">
+            <a:spAutoFit/>
+          </a:bodyPr>
+          <a:lstStyle/>
+          <a:p>
+            <a:r>
+              <a:rPr lang="en-US" dirty="0"/>
+              <a:t>Zone A: 60k€/MW</a:t>
+            </a:r>
+          </a:p>
+          <a:p>
+            <a:r>
+              <a:rPr lang="en-US" dirty="0"/>
+              <a:t>Zone B: 70k€/MW</a:t>
+            </a:r>
+          </a:p>
+          <a:p>
+            <a:r>
+              <a:rPr lang="en-US" dirty="0"/>
+              <a:t>Zone C: 80k€/MW</a:t>
+            </a:r>
+          </a:p>
+          <a:p>
+            <a:endParaRPr lang="nl-NL" dirty="0"/>
+          </a:p>
+        </p:txBody>
+      </p:sp>
+      <p:sp>
+        <p:nvSpPr>
+          <p:cNvPr id="5" name="TextBox 4">
+            <a:extLst>
+              <a:ext uri="{FF2B5EF4-FFF2-40B4-BE49-F238E27FC236}">
+                <a16:creationId xmlns:a16="http://schemas.microsoft.com/office/drawing/2014/main" id="{1977516C-8C54-A47D-5B72-C00BAA823140}"/>
+              </a:ext>
+            </a:extLst>
+          </p:cNvPr>
+          <p:cNvSpPr txBox="1"/>
+          <p:nvPr/>
+        </p:nvSpPr>
+        <p:spPr>
+          <a:xfrm>
+            <a:off x="1757934" y="3787170"/>
+            <a:ext cx="5267706" cy="369332"/>
+          </a:xfrm>
+          <a:prstGeom prst="rect">
+            <a:avLst/>
+          </a:prstGeom>
+          <a:noFill/>
+        </p:spPr>
+        <p:txBody>
+          <a:bodyPr wrap="square">
+            <a:spAutoFit/>
+          </a:bodyPr>
+          <a:lstStyle/>
+          <a:p>
+            <a:r>
+              <a:rPr lang="en-US" dirty="0"/>
+              <a:t>Using EOM as baseline</a:t>
             </a:r>
             <a:endParaRPr lang="nl-NL" dirty="0"/>
           </a:p>
@@ -4269,7 +6276,7 @@
     </p:spTree>
     <p:extLst>
       <p:ext uri="{BB962C8B-B14F-4D97-AF65-F5344CB8AC3E}">
-        <p14:creationId xmlns:p14="http://schemas.microsoft.com/office/powerpoint/2010/main" val="3125131823"/>
+        <p14:creationId xmlns:p14="http://schemas.microsoft.com/office/powerpoint/2010/main" val="2545728702"/>
       </p:ext>
     </p:extLst>
   </p:cSld>
@@ -4592,4 +6599,319 @@
     </a:ext>
   </a:extLst>
 </a:theme>
+</file>
+
+<file path=ppt/theme/theme2.xml><?xml version="1.0" encoding="utf-8"?>
+<a:theme xmlns:a="http://schemas.openxmlformats.org/drawingml/2006/main" name="Office Theme">
+  <a:themeElements>
+    <a:clrScheme name="Office">
+      <a:dk1>
+        <a:sysClr val="windowText" lastClr="000000"/>
+      </a:dk1>
+      <a:lt1>
+        <a:sysClr val="window" lastClr="FFFFFF"/>
+      </a:lt1>
+      <a:dk2>
+        <a:srgbClr val="0E2841"/>
+      </a:dk2>
+      <a:lt2>
+        <a:srgbClr val="E8E8E8"/>
+      </a:lt2>
+      <a:accent1>
+        <a:srgbClr val="156082"/>
+      </a:accent1>
+      <a:accent2>
+        <a:srgbClr val="E97132"/>
+      </a:accent2>
+      <a:accent3>
+        <a:srgbClr val="196B24"/>
+      </a:accent3>
+      <a:accent4>
+        <a:srgbClr val="0F9ED5"/>
+      </a:accent4>
+      <a:accent5>
+        <a:srgbClr val="A02B93"/>
+      </a:accent5>
+      <a:accent6>
+        <a:srgbClr val="4EA72E"/>
+      </a:accent6>
+      <a:hlink>
+        <a:srgbClr val="467886"/>
+      </a:hlink>
+      <a:folHlink>
+        <a:srgbClr val="96607D"/>
+      </a:folHlink>
+    </a:clrScheme>
+    <a:fontScheme name="Office">
+      <a:majorFont>
+        <a:latin typeface="Aptos Display" panose="02110004020202020204"/>
+        <a:ea typeface=""/>
+        <a:cs typeface=""/>
+        <a:font script="Jpan" typeface="游ゴシック Light"/>
+        <a:font script="Hang" typeface="맑은 고딕"/>
+        <a:font script="Hans" typeface="等线 Light"/>
+        <a:font script="Hant" typeface="新細明體"/>
+        <a:font script="Arab" typeface="Times New Roman"/>
+        <a:font script="Hebr" typeface="Times New Roman"/>
+        <a:font script="Thai" typeface="Angsana New"/>
+        <a:font script="Ethi" typeface="Nyala"/>
+        <a:font script="Beng" typeface="Vrinda"/>
+        <a:font script="Gujr" typeface="Shruti"/>
+        <a:font script="Khmr" typeface="MoolBoran"/>
+        <a:font script="Knda" typeface="Tunga"/>
+        <a:font script="Guru" typeface="Raavi"/>
+        <a:font script="Cans" typeface="Euphemia"/>
+        <a:font script="Cher" typeface="Plantagenet Cherokee"/>
+        <a:font script="Yiii" typeface="Microsoft Yi Baiti"/>
+        <a:font script="Tibt" typeface="Microsoft Himalaya"/>
+        <a:font script="Thaa" typeface="MV Boli"/>
+        <a:font script="Deva" typeface="Mangal"/>
+        <a:font script="Telu" typeface="Gautami"/>
+        <a:font script="Taml" typeface="Latha"/>
+        <a:font script="Syrc" typeface="Estrangelo Edessa"/>
+        <a:font script="Orya" typeface="Kalinga"/>
+        <a:font script="Mlym" typeface="Kartika"/>
+        <a:font script="Laoo" typeface="DokChampa"/>
+        <a:font script="Sinh" typeface="Iskoola Pota"/>
+        <a:font script="Mong" typeface="Mongolian Baiti"/>
+        <a:font script="Viet" typeface="Times New Roman"/>
+        <a:font script="Uigh" typeface="Microsoft Uighur"/>
+        <a:font script="Geor" typeface="Sylfaen"/>
+        <a:font script="Armn" typeface="Arial"/>
+        <a:font script="Bugi" typeface="Leelawadee UI"/>
+        <a:font script="Bopo" typeface="Microsoft JhengHei"/>
+        <a:font script="Java" typeface="Javanese Text"/>
+        <a:font script="Lisu" typeface="Segoe UI"/>
+        <a:font script="Mymr" typeface="Myanmar Text"/>
+        <a:font script="Nkoo" typeface="Ebrima"/>
+        <a:font script="Olck" typeface="Nirmala UI"/>
+        <a:font script="Osma" typeface="Ebrima"/>
+        <a:font script="Phag" typeface="Phagspa"/>
+        <a:font script="Syrn" typeface="Estrangelo Edessa"/>
+        <a:font script="Syrj" typeface="Estrangelo Edessa"/>
+        <a:font script="Syre" typeface="Estrangelo Edessa"/>
+        <a:font script="Sora" typeface="Nirmala UI"/>
+        <a:font script="Tale" typeface="Microsoft Tai Le"/>
+        <a:font script="Talu" typeface="Microsoft New Tai Lue"/>
+        <a:font script="Tfng" typeface="Ebrima"/>
+      </a:majorFont>
+      <a:minorFont>
+        <a:latin typeface="Aptos" panose="02110004020202020204"/>
+        <a:ea typeface=""/>
+        <a:cs typeface=""/>
+        <a:font script="Jpan" typeface="游ゴシック"/>
+        <a:font script="Hang" typeface="맑은 고딕"/>
+        <a:font script="Hans" typeface="等线"/>
+        <a:font script="Hant" typeface="新細明體"/>
+        <a:font script="Arab" typeface="Arial"/>
+        <a:font script="Hebr" typeface="Arial"/>
+        <a:font script="Thai" typeface="Cordia New"/>
+        <a:font script="Ethi" typeface="Nyala"/>
+        <a:font script="Beng" typeface="Vrinda"/>
+        <a:font script="Gujr" typeface="Shruti"/>
+        <a:font script="Khmr" typeface="DaunPenh"/>
+        <a:font script="Knda" typeface="Tunga"/>
+        <a:font script="Guru" typeface="Raavi"/>
+        <a:font script="Cans" typeface="Euphemia"/>
+        <a:font script="Cher" typeface="Plantagenet Cherokee"/>
+        <a:font script="Yiii" typeface="Microsoft Yi Baiti"/>
+        <a:font script="Tibt" typeface="Microsoft Himalaya"/>
+        <a:font script="Thaa" typeface="MV Boli"/>
+        <a:font script="Deva" typeface="Mangal"/>
+        <a:font script="Telu" typeface="Gautami"/>
+        <a:font script="Taml" typeface="Latha"/>
+        <a:font script="Syrc" typeface="Estrangelo Edessa"/>
+        <a:font script="Orya" typeface="Kalinga"/>
+        <a:font script="Mlym" typeface="Kartika"/>
+        <a:font script="Laoo" typeface="DokChampa"/>
+        <a:font script="Sinh" typeface="Iskoola Pota"/>
+        <a:font script="Mong" typeface="Mongolian Baiti"/>
+        <a:font script="Viet" typeface="Arial"/>
+        <a:font script="Uigh" typeface="Microsoft Uighur"/>
+        <a:font script="Geor" typeface="Sylfaen"/>
+        <a:font script="Armn" typeface="Arial"/>
+        <a:font script="Bugi" typeface="Leelawadee UI"/>
+        <a:font script="Bopo" typeface="Microsoft JhengHei"/>
+        <a:font script="Java" typeface="Javanese Text"/>
+        <a:font script="Lisu" typeface="Segoe UI"/>
+        <a:font script="Mymr" typeface="Myanmar Text"/>
+        <a:font script="Nkoo" typeface="Ebrima"/>
+        <a:font script="Olck" typeface="Nirmala UI"/>
+        <a:font script="Osma" typeface="Ebrima"/>
+        <a:font script="Phag" typeface="Phagspa"/>
+        <a:font script="Syrn" typeface="Estrangelo Edessa"/>
+        <a:font script="Syrj" typeface="Estrangelo Edessa"/>
+        <a:font script="Syre" typeface="Estrangelo Edessa"/>
+        <a:font script="Sora" typeface="Nirmala UI"/>
+        <a:font script="Tale" typeface="Microsoft Tai Le"/>
+        <a:font script="Talu" typeface="Microsoft New Tai Lue"/>
+        <a:font script="Tfng" typeface="Ebrima"/>
+      </a:minorFont>
+    </a:fontScheme>
+    <a:fmtScheme name="Office">
+      <a:fillStyleLst>
+        <a:solidFill>
+          <a:schemeClr val="phClr"/>
+        </a:solidFill>
+        <a:gradFill rotWithShape="1">
+          <a:gsLst>
+            <a:gs pos="0">
+              <a:schemeClr val="phClr">
+                <a:lumMod val="110000"/>
+                <a:satMod val="105000"/>
+                <a:tint val="67000"/>
+              </a:schemeClr>
+            </a:gs>
+            <a:gs pos="50000">
+              <a:schemeClr val="phClr">
+                <a:lumMod val="105000"/>
+                <a:satMod val="103000"/>
+                <a:tint val="73000"/>
+              </a:schemeClr>
+            </a:gs>
+            <a:gs pos="100000">
+              <a:schemeClr val="phClr">
+                <a:lumMod val="105000"/>
+                <a:satMod val="109000"/>
+                <a:tint val="81000"/>
+              </a:schemeClr>
+            </a:gs>
+          </a:gsLst>
+          <a:lin ang="5400000" scaled="0"/>
+        </a:gradFill>
+        <a:gradFill rotWithShape="1">
+          <a:gsLst>
+            <a:gs pos="0">
+              <a:schemeClr val="phClr">
+                <a:satMod val="103000"/>
+                <a:lumMod val="102000"/>
+                <a:tint val="94000"/>
+              </a:schemeClr>
+            </a:gs>
+            <a:gs pos="50000">
+              <a:schemeClr val="phClr">
+                <a:satMod val="110000"/>
+                <a:lumMod val="100000"/>
+                <a:shade val="100000"/>
+              </a:schemeClr>
+            </a:gs>
+            <a:gs pos="100000">
+              <a:schemeClr val="phClr">
+                <a:lumMod val="99000"/>
+                <a:satMod val="120000"/>
+                <a:shade val="78000"/>
+              </a:schemeClr>
+            </a:gs>
+          </a:gsLst>
+          <a:lin ang="5400000" scaled="0"/>
+        </a:gradFill>
+      </a:fillStyleLst>
+      <a:lnStyleLst>
+        <a:ln w="12700" cap="flat" cmpd="sng" algn="ctr">
+          <a:solidFill>
+            <a:schemeClr val="phClr"/>
+          </a:solidFill>
+          <a:prstDash val="solid"/>
+          <a:miter lim="800000"/>
+        </a:ln>
+        <a:ln w="19050" cap="flat" cmpd="sng" algn="ctr">
+          <a:solidFill>
+            <a:schemeClr val="phClr"/>
+          </a:solidFill>
+          <a:prstDash val="solid"/>
+          <a:miter lim="800000"/>
+        </a:ln>
+        <a:ln w="25400" cap="flat" cmpd="sng" algn="ctr">
+          <a:solidFill>
+            <a:schemeClr val="phClr"/>
+          </a:solidFill>
+          <a:prstDash val="solid"/>
+          <a:miter lim="800000"/>
+        </a:ln>
+      </a:lnStyleLst>
+      <a:effectStyleLst>
+        <a:effectStyle>
+          <a:effectLst/>
+        </a:effectStyle>
+        <a:effectStyle>
+          <a:effectLst/>
+        </a:effectStyle>
+        <a:effectStyle>
+          <a:effectLst>
+            <a:outerShdw blurRad="57150" dist="19050" dir="5400000" algn="ctr" rotWithShape="0">
+              <a:srgbClr val="000000">
+                <a:alpha val="63000"/>
+              </a:srgbClr>
+            </a:outerShdw>
+          </a:effectLst>
+        </a:effectStyle>
+      </a:effectStyleLst>
+      <a:bgFillStyleLst>
+        <a:solidFill>
+          <a:schemeClr val="phClr"/>
+        </a:solidFill>
+        <a:solidFill>
+          <a:schemeClr val="phClr">
+            <a:tint val="95000"/>
+            <a:satMod val="170000"/>
+          </a:schemeClr>
+        </a:solidFill>
+        <a:gradFill rotWithShape="1">
+          <a:gsLst>
+            <a:gs pos="0">
+              <a:schemeClr val="phClr">
+                <a:tint val="93000"/>
+                <a:satMod val="150000"/>
+                <a:shade val="98000"/>
+                <a:lumMod val="102000"/>
+              </a:schemeClr>
+            </a:gs>
+            <a:gs pos="50000">
+              <a:schemeClr val="phClr">
+                <a:tint val="98000"/>
+                <a:satMod val="130000"/>
+                <a:shade val="90000"/>
+                <a:lumMod val="103000"/>
+              </a:schemeClr>
+            </a:gs>
+            <a:gs pos="100000">
+              <a:schemeClr val="phClr">
+                <a:shade val="63000"/>
+                <a:satMod val="120000"/>
+              </a:schemeClr>
+            </a:gs>
+          </a:gsLst>
+          <a:lin ang="5400000" scaled="0"/>
+        </a:gradFill>
+      </a:bgFillStyleLst>
+    </a:fmtScheme>
+  </a:themeElements>
+  <a:objectDefaults>
+    <a:lnDef>
+      <a:spPr/>
+      <a:bodyPr/>
+      <a:lstStyle/>
+      <a:style>
+        <a:lnRef idx="2">
+          <a:schemeClr val="accent1"/>
+        </a:lnRef>
+        <a:fillRef idx="0">
+          <a:schemeClr val="accent1"/>
+        </a:fillRef>
+        <a:effectRef idx="1">
+          <a:schemeClr val="accent1"/>
+        </a:effectRef>
+        <a:fontRef idx="minor">
+          <a:schemeClr val="tx1"/>
+        </a:fontRef>
+      </a:style>
+    </a:lnDef>
+  </a:objectDefaults>
+  <a:extraClrSchemeLst/>
+  <a:extLst>
+    <a:ext uri="{05A4C25C-085E-4340-85A3-A5531E510DB2}">
+      <thm15:themeFamily xmlns:thm15="http://schemas.microsoft.com/office/thememl/2012/main" name="Office Theme" id="{2E142A2C-CD16-42D6-873A-C26D2A0506FA}" vid="{1BDDFF52-6CD6-40A5-AB3C-68EB2F1E4D0A}"/>
+    </a:ext>
+  </a:extLst>
+</a:theme>
 </file>
</xml_diff>